<commit_message>
Update weekly digest - 2025-12-15
</commit_message>
<xml_diff>
--- a/AI_Weekly_2025-12-15.pptx
+++ b/AI_Weekly_2025-12-15.pptx
@@ -25,11 +25,6 @@
     <p:sldId id="273" r:id="rId24"/>
     <p:sldId id="274" r:id="rId25"/>
     <p:sldId id="275" r:id="rId26"/>
-    <p:sldId id="276" r:id="rId27"/>
-    <p:sldId id="277" r:id="rId28"/>
-    <p:sldId id="278" r:id="rId29"/>
-    <p:sldId id="279" r:id="rId30"/>
-    <p:sldId id="280" r:id="rId31"/>
   </p:sldIdLst>
   <p:sldSz cx="9144000" cy="6858000" type="screen4x3"/>
   <p:notesSz cx="6858000" cy="9144000"/>
@@ -3221,63 +3216,66 @@
       <p:grpSpPr/>
       <p:sp>
         <p:nvSpPr>
-          <p:cNvPr id="2" name="Title 1"/>
-          <p:cNvSpPr>
-            <a:spLocks noGrp="1"/>
-          </p:cNvSpPr>
-          <p:nvPr>
-            <p:ph type="title"/>
-          </p:nvPr>
-        </p:nvSpPr>
-        <p:spPr/>
-        <p:txBody>
-          <a:bodyPr/>
-          <a:lstStyle/>
-          <a:p>
-            <a:r>
-              <a:t>1. AI agents are starting to eat SaaS</a:t>
-            </a:r>
-          </a:p>
-        </p:txBody>
-      </p:sp>
-      <p:sp>
-        <p:nvSpPr>
-          <p:cNvPr id="3" name="Content Placeholder 2"/>
-          <p:cNvSpPr>
-            <a:spLocks noGrp="1"/>
-          </p:cNvSpPr>
-          <p:nvPr>
-            <p:ph idx="1"/>
-          </p:nvPr>
-        </p:nvSpPr>
-        <p:spPr/>
-        <p:txBody>
-          <a:bodyPr/>
-          <a:lstStyle/>
-          <a:p>
-            <a:r>
-              <a:t>Signals the beginning of AI agents disrupting traditional SaaS business models by</a:t>
-            </a:r>
-          </a:p>
-          <a:p>
-            <a:pPr/>
-            <a:r>
-              <a:t>automating tasks previously requiring dedicated software platforms.</a:t>
-            </a:r>
-          </a:p>
-          <a:p>
-            <a:pPr/>
-          </a:p>
-          <a:p>
-            <a:pPr/>
-            <a:r>
-              <a:t>📍 Hacker News • 119 points • 138 comments</a:t>
-            </a:r>
-          </a:p>
-          <a:p>
-            <a:pPr/>
-            <a:r>
-              <a:t>🔗 https://martinalderson.com/posts/ai-agents-are-starting-to-eat-saas/</a:t>
+          <p:cNvPr id="2" name="TextBox 1"/>
+          <p:cNvSpPr txBox="1"/>
+          <p:nvPr/>
+        </p:nvSpPr>
+        <p:spPr>
+          <a:xfrm>
+            <a:off x="457200" y="457200"/>
+            <a:ext cx="8229600" cy="685800"/>
+          </a:xfrm>
+          <a:prstGeom prst="rect">
+            <a:avLst/>
+          </a:prstGeom>
+          <a:noFill/>
+        </p:spPr>
+        <p:txBody>
+          <a:bodyPr wrap="none">
+            <a:spAutoFit/>
+          </a:bodyPr>
+          <a:lstStyle/>
+          <a:p>
+            <a:pPr>
+              <a:defRPr sz="3200" b="1"/>
+            </a:pPr>
+            <a:r>
+              <a:t>1. OpenAI are quietly adopting skills, now available in ChatGPT and Codex CLI</a:t>
+            </a:r>
+          </a:p>
+        </p:txBody>
+      </p:sp>
+      <p:sp>
+        <p:nvSpPr>
+          <p:cNvPr id="3" name="TextBox 2"/>
+          <p:cNvSpPr txBox="1"/>
+          <p:nvPr/>
+        </p:nvSpPr>
+        <p:spPr>
+          <a:xfrm>
+            <a:off x="457200" y="1371600"/>
+            <a:ext cx="8229600" cy="685800"/>
+          </a:xfrm>
+          <a:prstGeom prst="rect">
+            <a:avLst/>
+          </a:prstGeom>
+          <a:noFill/>
+        </p:spPr>
+        <p:txBody>
+          <a:bodyPr wrap="none">
+            <a:spAutoFit/>
+          </a:bodyPr>
+          <a:lstStyle/>
+          <a:p>
+            <a:pPr>
+              <a:defRPr sz="1100">
+                <a:solidFill>
+                  <a:srgbClr val="333333"/>
+                </a:solidFill>
+              </a:defRPr>
+            </a:pPr>
+            <a:r>
+              <a:t>OpenAI's stealth launch of 'skills' represents a significant shift toward modular agent capabilities, enabling ChatGPT to perform specialized tool-based tasks through composable functions.</a:t>
             </a:r>
           </a:p>
         </p:txBody>
@@ -3285,6 +3283,104 @@
       <p:sp>
         <p:nvSpPr>
           <p:cNvPr id="4" name="TextBox 3"/>
+          <p:cNvSpPr txBox="1"/>
+          <p:nvPr/>
+        </p:nvSpPr>
+        <p:spPr>
+          <a:xfrm>
+            <a:off x="457200" y="2057400"/>
+            <a:ext cx="8229600" cy="685800"/>
+          </a:xfrm>
+          <a:prstGeom prst="rect">
+            <a:avLst/>
+          </a:prstGeom>
+          <a:noFill/>
+        </p:spPr>
+        <p:txBody>
+          <a:bodyPr wrap="none">
+            <a:spAutoFit/>
+          </a:bodyPr>
+          <a:lstStyle/>
+          <a:p>
+            <a:pPr>
+              <a:defRPr sz="800"/>
+            </a:pPr>
+          </a:p>
+        </p:txBody>
+      </p:sp>
+      <p:sp>
+        <p:nvSpPr>
+          <p:cNvPr id="5" name="TextBox 4"/>
+          <p:cNvSpPr txBox="1"/>
+          <p:nvPr/>
+        </p:nvSpPr>
+        <p:spPr>
+          <a:xfrm>
+            <a:off x="457200" y="2743200"/>
+            <a:ext cx="8229600" cy="685800"/>
+          </a:xfrm>
+          <a:prstGeom prst="rect">
+            <a:avLst/>
+          </a:prstGeom>
+          <a:noFill/>
+        </p:spPr>
+        <p:txBody>
+          <a:bodyPr wrap="none">
+            <a:spAutoFit/>
+          </a:bodyPr>
+          <a:lstStyle/>
+          <a:p>
+            <a:pPr>
+              <a:defRPr sz="900" i="1">
+                <a:solidFill>
+                  <a:srgbClr val="666666"/>
+                </a:solidFill>
+              </a:defRPr>
+            </a:pPr>
+            <a:r>
+              <a:t>📍 Hacker News • 568 points • 314 comments</a:t>
+            </a:r>
+          </a:p>
+        </p:txBody>
+      </p:sp>
+      <p:sp>
+        <p:nvSpPr>
+          <p:cNvPr id="6" name="TextBox 5"/>
+          <p:cNvSpPr txBox="1"/>
+          <p:nvPr/>
+        </p:nvSpPr>
+        <p:spPr>
+          <a:xfrm>
+            <a:off x="457200" y="3429000"/>
+            <a:ext cx="8229600" cy="685800"/>
+          </a:xfrm>
+          <a:prstGeom prst="rect">
+            <a:avLst/>
+          </a:prstGeom>
+          <a:noFill/>
+        </p:spPr>
+        <p:txBody>
+          <a:bodyPr wrap="none">
+            <a:spAutoFit/>
+          </a:bodyPr>
+          <a:lstStyle/>
+          <a:p>
+            <a:pPr>
+              <a:defRPr sz="800">
+                <a:solidFill>
+                  <a:srgbClr val="3498DB"/>
+                </a:solidFill>
+              </a:defRPr>
+            </a:pPr>
+            <a:r>
+              <a:t>🔗 https://simonwillison.net/2025/Dec/12/openai-skills/</a:t>
+            </a:r>
+          </a:p>
+        </p:txBody>
+      </p:sp>
+      <p:sp>
+        <p:nvSpPr>
+          <p:cNvPr id="7" name="TextBox 6"/>
           <p:cNvSpPr txBox="1"/>
           <p:nvPr/>
         </p:nvSpPr>
@@ -3341,69 +3437,66 @@
       <p:grpSpPr/>
       <p:sp>
         <p:nvSpPr>
-          <p:cNvPr id="2" name="Title 1"/>
-          <p:cNvSpPr>
-            <a:spLocks noGrp="1"/>
-          </p:cNvSpPr>
-          <p:nvPr>
-            <p:ph type="title"/>
-          </p:nvPr>
-        </p:nvSpPr>
-        <p:spPr/>
-        <p:txBody>
-          <a:bodyPr/>
-          <a:lstStyle/>
-          <a:p>
-            <a:r>
-              <a:t>2. OpenAI are quietly adopting skills, now available in ChatGPT and Codex CLI</a:t>
-            </a:r>
-          </a:p>
-        </p:txBody>
-      </p:sp>
-      <p:sp>
-        <p:nvSpPr>
-          <p:cNvPr id="3" name="Content Placeholder 2"/>
-          <p:cNvSpPr>
-            <a:spLocks noGrp="1"/>
-          </p:cNvSpPr>
-          <p:nvPr>
-            <p:ph idx="1"/>
-          </p:nvPr>
-        </p:nvSpPr>
-        <p:spPr/>
-        <p:txBody>
-          <a:bodyPr/>
-          <a:lstStyle/>
-          <a:p>
-            <a:r>
-              <a:t>OpenAI introduces 'skills' functionality enabling more modular and extensible agent</a:t>
-            </a:r>
-          </a:p>
-          <a:p>
-            <a:pPr/>
-            <a:r>
-              <a:t>capabilities in their production systems, indicating shift toward agent-based</a:t>
-            </a:r>
-          </a:p>
-          <a:p>
-            <a:pPr/>
-            <a:r>
-              <a:t>architectures.</a:t>
-            </a:r>
-          </a:p>
-          <a:p>
-            <a:pPr/>
-          </a:p>
-          <a:p>
-            <a:pPr/>
-            <a:r>
-              <a:t>📍 Hacker News • 568 points • 313 comments</a:t>
-            </a:r>
-          </a:p>
-          <a:p>
-            <a:pPr/>
-            <a:r>
-              <a:t>🔗 https://simonwillison.net/2025/Dec/12/openai-skills/</a:t>
+          <p:cNvPr id="2" name="TextBox 1"/>
+          <p:cNvSpPr txBox="1"/>
+          <p:nvPr/>
+        </p:nvSpPr>
+        <p:spPr>
+          <a:xfrm>
+            <a:off x="457200" y="457200"/>
+            <a:ext cx="8229600" cy="685800"/>
+          </a:xfrm>
+          <a:prstGeom prst="rect">
+            <a:avLst/>
+          </a:prstGeom>
+          <a:noFill/>
+        </p:spPr>
+        <p:txBody>
+          <a:bodyPr wrap="none">
+            <a:spAutoFit/>
+          </a:bodyPr>
+          <a:lstStyle/>
+          <a:p>
+            <a:pPr>
+              <a:defRPr sz="3200" b="1"/>
+            </a:pPr>
+            <a:r>
+              <a:t>2. AI agents are starting to eat SaaS</a:t>
+            </a:r>
+          </a:p>
+        </p:txBody>
+      </p:sp>
+      <p:sp>
+        <p:nvSpPr>
+          <p:cNvPr id="3" name="TextBox 2"/>
+          <p:cNvSpPr txBox="1"/>
+          <p:nvPr/>
+        </p:nvSpPr>
+        <p:spPr>
+          <a:xfrm>
+            <a:off x="457200" y="1371600"/>
+            <a:ext cx="8229600" cy="685800"/>
+          </a:xfrm>
+          <a:prstGeom prst="rect">
+            <a:avLst/>
+          </a:prstGeom>
+          <a:noFill/>
+        </p:spPr>
+        <p:txBody>
+          <a:bodyPr wrap="none">
+            <a:spAutoFit/>
+          </a:bodyPr>
+          <a:lstStyle/>
+          <a:p>
+            <a:pPr>
+              <a:defRPr sz="1100">
+                <a:solidFill>
+                  <a:srgbClr val="333333"/>
+                </a:solidFill>
+              </a:defRPr>
+            </a:pPr>
+            <a:r>
+              <a:t>Analysis of how autonomous AI agents are beginning to replace traditional SaaS products by automating entire workflows rather than just individual tasks.</a:t>
             </a:r>
           </a:p>
         </p:txBody>
@@ -3411,6 +3504,104 @@
       <p:sp>
         <p:nvSpPr>
           <p:cNvPr id="4" name="TextBox 3"/>
+          <p:cNvSpPr txBox="1"/>
+          <p:nvPr/>
+        </p:nvSpPr>
+        <p:spPr>
+          <a:xfrm>
+            <a:off x="457200" y="2057400"/>
+            <a:ext cx="8229600" cy="685800"/>
+          </a:xfrm>
+          <a:prstGeom prst="rect">
+            <a:avLst/>
+          </a:prstGeom>
+          <a:noFill/>
+        </p:spPr>
+        <p:txBody>
+          <a:bodyPr wrap="none">
+            <a:spAutoFit/>
+          </a:bodyPr>
+          <a:lstStyle/>
+          <a:p>
+            <a:pPr>
+              <a:defRPr sz="800"/>
+            </a:pPr>
+          </a:p>
+        </p:txBody>
+      </p:sp>
+      <p:sp>
+        <p:nvSpPr>
+          <p:cNvPr id="5" name="TextBox 4"/>
+          <p:cNvSpPr txBox="1"/>
+          <p:nvPr/>
+        </p:nvSpPr>
+        <p:spPr>
+          <a:xfrm>
+            <a:off x="457200" y="2743200"/>
+            <a:ext cx="8229600" cy="685800"/>
+          </a:xfrm>
+          <a:prstGeom prst="rect">
+            <a:avLst/>
+          </a:prstGeom>
+          <a:noFill/>
+        </p:spPr>
+        <p:txBody>
+          <a:bodyPr wrap="none">
+            <a:spAutoFit/>
+          </a:bodyPr>
+          <a:lstStyle/>
+          <a:p>
+            <a:pPr>
+              <a:defRPr sz="900" i="1">
+                <a:solidFill>
+                  <a:srgbClr val="666666"/>
+                </a:solidFill>
+              </a:defRPr>
+            </a:pPr>
+            <a:r>
+              <a:t>📍 Hacker News • 123 points • 144 comments</a:t>
+            </a:r>
+          </a:p>
+        </p:txBody>
+      </p:sp>
+      <p:sp>
+        <p:nvSpPr>
+          <p:cNvPr id="6" name="TextBox 5"/>
+          <p:cNvSpPr txBox="1"/>
+          <p:nvPr/>
+        </p:nvSpPr>
+        <p:spPr>
+          <a:xfrm>
+            <a:off x="457200" y="3429000"/>
+            <a:ext cx="8229600" cy="685800"/>
+          </a:xfrm>
+          <a:prstGeom prst="rect">
+            <a:avLst/>
+          </a:prstGeom>
+          <a:noFill/>
+        </p:spPr>
+        <p:txBody>
+          <a:bodyPr wrap="none">
+            <a:spAutoFit/>
+          </a:bodyPr>
+          <a:lstStyle/>
+          <a:p>
+            <a:pPr>
+              <a:defRPr sz="800">
+                <a:solidFill>
+                  <a:srgbClr val="3498DB"/>
+                </a:solidFill>
+              </a:defRPr>
+            </a:pPr>
+            <a:r>
+              <a:t>🔗 https://martinalderson.com/posts/ai-agents-are-starting-t...</a:t>
+            </a:r>
+          </a:p>
+        </p:txBody>
+      </p:sp>
+      <p:sp>
+        <p:nvSpPr>
+          <p:cNvPr id="7" name="TextBox 6"/>
           <p:cNvSpPr txBox="1"/>
           <p:nvPr/>
         </p:nvSpPr>
@@ -3467,19 +3658,29 @@
       <p:grpSpPr/>
       <p:sp>
         <p:nvSpPr>
-          <p:cNvPr id="2" name="Title 1"/>
-          <p:cNvSpPr>
-            <a:spLocks noGrp="1"/>
-          </p:cNvSpPr>
-          <p:nvPr>
-            <p:ph type="title"/>
-          </p:nvPr>
-        </p:nvSpPr>
-        <p:spPr/>
-        <p:txBody>
-          <a:bodyPr/>
-          <a:lstStyle/>
-          <a:p>
+          <p:cNvPr id="2" name="TextBox 1"/>
+          <p:cNvSpPr txBox="1"/>
+          <p:nvPr/>
+        </p:nvSpPr>
+        <p:spPr>
+          <a:xfrm>
+            <a:off x="457200" y="457200"/>
+            <a:ext cx="8229600" cy="685800"/>
+          </a:xfrm>
+          <a:prstGeom prst="rect">
+            <a:avLst/>
+          </a:prstGeom>
+          <a:noFill/>
+        </p:spPr>
+        <p:txBody>
+          <a:bodyPr wrap="none">
+            <a:spAutoFit/>
+          </a:bodyPr>
+          <a:lstStyle/>
+          <a:p>
+            <a:pPr>
+              <a:defRPr sz="3200" b="1"/>
+            </a:pPr>
             <a:r>
               <a:t>3. Claude CLI deleted my home directory and wiped my Mac</a:t>
             </a:r>
@@ -3488,42 +3689,35 @@
       </p:sp>
       <p:sp>
         <p:nvSpPr>
-          <p:cNvPr id="3" name="Content Placeholder 2"/>
-          <p:cNvSpPr>
-            <a:spLocks noGrp="1"/>
-          </p:cNvSpPr>
-          <p:nvPr>
-            <p:ph idx="1"/>
-          </p:nvPr>
-        </p:nvSpPr>
-        <p:spPr/>
-        <p:txBody>
-          <a:bodyPr/>
-          <a:lstStyle/>
-          <a:p>
-            <a:r>
-              <a:t>Highlights critical safety challenges in tool-using agents with system access,</a:t>
-            </a:r>
-          </a:p>
-          <a:p>
-            <a:pPr/>
-            <a:r>
-              <a:t>demonstrating urgent need for better guardrails in autonomous agent deployments.</a:t>
-            </a:r>
-          </a:p>
-          <a:p>
-            <a:pPr/>
-          </a:p>
-          <a:p>
-            <a:pPr/>
-            <a:r>
-              <a:t>📍 Hacker News • 220 points • 179 comments</a:t>
-            </a:r>
-          </a:p>
-          <a:p>
-            <a:pPr/>
-            <a:r>
-              <a:t>🔗 https://old.reddit.com/r/ClaudeAI/comments/1pgxckk/claude_cli_deleted_my...</a:t>
+          <p:cNvPr id="3" name="TextBox 2"/>
+          <p:cNvSpPr txBox="1"/>
+          <p:nvPr/>
+        </p:nvSpPr>
+        <p:spPr>
+          <a:xfrm>
+            <a:off x="457200" y="1371600"/>
+            <a:ext cx="8229600" cy="685800"/>
+          </a:xfrm>
+          <a:prstGeom prst="rect">
+            <a:avLst/>
+          </a:prstGeom>
+          <a:noFill/>
+        </p:spPr>
+        <p:txBody>
+          <a:bodyPr wrap="none">
+            <a:spAutoFit/>
+          </a:bodyPr>
+          <a:lstStyle/>
+          <a:p>
+            <a:pPr>
+              <a:defRPr sz="1100">
+                <a:solidFill>
+                  <a:srgbClr val="333333"/>
+                </a:solidFill>
+              </a:defRPr>
+            </a:pPr>
+            <a:r>
+              <a:t>Critical incident highlighting the safety challenges of giving AI agents unrestricted tool access and file system permissions, underscoring the need for better guardrails in agentic systems.</a:t>
             </a:r>
           </a:p>
         </p:txBody>
@@ -3531,6 +3725,104 @@
       <p:sp>
         <p:nvSpPr>
           <p:cNvPr id="4" name="TextBox 3"/>
+          <p:cNvSpPr txBox="1"/>
+          <p:nvPr/>
+        </p:nvSpPr>
+        <p:spPr>
+          <a:xfrm>
+            <a:off x="457200" y="2057400"/>
+            <a:ext cx="8229600" cy="685800"/>
+          </a:xfrm>
+          <a:prstGeom prst="rect">
+            <a:avLst/>
+          </a:prstGeom>
+          <a:noFill/>
+        </p:spPr>
+        <p:txBody>
+          <a:bodyPr wrap="none">
+            <a:spAutoFit/>
+          </a:bodyPr>
+          <a:lstStyle/>
+          <a:p>
+            <a:pPr>
+              <a:defRPr sz="800"/>
+            </a:pPr>
+          </a:p>
+        </p:txBody>
+      </p:sp>
+      <p:sp>
+        <p:nvSpPr>
+          <p:cNvPr id="5" name="TextBox 4"/>
+          <p:cNvSpPr txBox="1"/>
+          <p:nvPr/>
+        </p:nvSpPr>
+        <p:spPr>
+          <a:xfrm>
+            <a:off x="457200" y="2743200"/>
+            <a:ext cx="8229600" cy="685800"/>
+          </a:xfrm>
+          <a:prstGeom prst="rect">
+            <a:avLst/>
+          </a:prstGeom>
+          <a:noFill/>
+        </p:spPr>
+        <p:txBody>
+          <a:bodyPr wrap="none">
+            <a:spAutoFit/>
+          </a:bodyPr>
+          <a:lstStyle/>
+          <a:p>
+            <a:pPr>
+              <a:defRPr sz="900" i="1">
+                <a:solidFill>
+                  <a:srgbClr val="666666"/>
+                </a:solidFill>
+              </a:defRPr>
+            </a:pPr>
+            <a:r>
+              <a:t>📍 Hacker News • 221 points • 181 comments</a:t>
+            </a:r>
+          </a:p>
+        </p:txBody>
+      </p:sp>
+      <p:sp>
+        <p:nvSpPr>
+          <p:cNvPr id="6" name="TextBox 5"/>
+          <p:cNvSpPr txBox="1"/>
+          <p:nvPr/>
+        </p:nvSpPr>
+        <p:spPr>
+          <a:xfrm>
+            <a:off x="457200" y="3429000"/>
+            <a:ext cx="8229600" cy="685800"/>
+          </a:xfrm>
+          <a:prstGeom prst="rect">
+            <a:avLst/>
+          </a:prstGeom>
+          <a:noFill/>
+        </p:spPr>
+        <p:txBody>
+          <a:bodyPr wrap="none">
+            <a:spAutoFit/>
+          </a:bodyPr>
+          <a:lstStyle/>
+          <a:p>
+            <a:pPr>
+              <a:defRPr sz="800">
+                <a:solidFill>
+                  <a:srgbClr val="3498DB"/>
+                </a:solidFill>
+              </a:defRPr>
+            </a:pPr>
+            <a:r>
+              <a:t>🔗 https://old.reddit.com/r/ClaudeAI/comments/1pgxckk/claude...</a:t>
+            </a:r>
+          </a:p>
+        </p:txBody>
+      </p:sp>
+      <p:sp>
+        <p:nvSpPr>
+          <p:cNvPr id="7" name="TextBox 6"/>
           <p:cNvSpPr txBox="1"/>
           <p:nvPr/>
         </p:nvSpPr>
@@ -3587,69 +3879,66 @@
       <p:grpSpPr/>
       <p:sp>
         <p:nvSpPr>
-          <p:cNvPr id="2" name="Title 1"/>
-          <p:cNvSpPr>
-            <a:spLocks noGrp="1"/>
-          </p:cNvSpPr>
-          <p:nvPr>
-            <p:ph type="title"/>
-          </p:nvPr>
-        </p:nvSpPr>
-        <p:spPr/>
-        <p:txBody>
-          <a:bodyPr/>
-          <a:lstStyle/>
-          <a:p>
-            <a:r>
-              <a:t>4. An AI agent spent 16 hours hacking Stanford's network. It outperformed h...</a:t>
-            </a:r>
-          </a:p>
-        </p:txBody>
-      </p:sp>
-      <p:sp>
-        <p:nvSpPr>
-          <p:cNvPr id="3" name="Content Placeholder 2"/>
-          <p:cNvSpPr>
-            <a:spLocks noGrp="1"/>
-          </p:cNvSpPr>
-          <p:nvPr>
-            <p:ph idx="1"/>
-          </p:nvPr>
-        </p:nvSpPr>
-        <p:spPr/>
-        <p:txBody>
-          <a:bodyPr/>
-          <a:lstStyle/>
-          <a:p>
-            <a:r>
-              <a:t>Demonstrates autonomous AI agents achieving expert-level performance in complex</a:t>
-            </a:r>
-          </a:p>
-          <a:p>
-            <a:pPr/>
-            <a:r>
-              <a:t>cybersecurity tasks, showcasing practical planning and tool-use capabilities in real-world</a:t>
-            </a:r>
-          </a:p>
-          <a:p>
-            <a:pPr/>
-            <a:r>
-              <a:t>adversarial scenarios.</a:t>
-            </a:r>
-          </a:p>
-          <a:p>
-            <a:pPr/>
-          </a:p>
-          <a:p>
-            <a:pPr/>
-            <a:r>
-              <a:t>📍 r/artificial • 206 upvotes • 32 comments</a:t>
-            </a:r>
-          </a:p>
-          <a:p>
-            <a:pPr/>
-            <a:r>
-              <a:t>🔗 https://reddit.com/r/artificial/comments/1pkuaaq/an_ai_agent_spent_16_ho...</a:t>
+          <p:cNvPr id="2" name="TextBox 1"/>
+          <p:cNvSpPr txBox="1"/>
+          <p:nvPr/>
+        </p:nvSpPr>
+        <p:spPr>
+          <a:xfrm>
+            <a:off x="457200" y="457200"/>
+            <a:ext cx="8229600" cy="685800"/>
+          </a:xfrm>
+          <a:prstGeom prst="rect">
+            <a:avLst/>
+          </a:prstGeom>
+          <a:noFill/>
+        </p:spPr>
+        <p:txBody>
+          <a:bodyPr wrap="none">
+            <a:spAutoFit/>
+          </a:bodyPr>
+          <a:lstStyle/>
+          <a:p>
+            <a:pPr>
+              <a:defRPr sz="3200" b="1"/>
+            </a:pPr>
+            <a:r>
+              <a:t>4. An AI agent spent 16 hours hacking Stanford's network. It outperformed human pros for much less than their 6-figure salaries.</a:t>
+            </a:r>
+          </a:p>
+        </p:txBody>
+      </p:sp>
+      <p:sp>
+        <p:nvSpPr>
+          <p:cNvPr id="3" name="TextBox 2"/>
+          <p:cNvSpPr txBox="1"/>
+          <p:nvPr/>
+        </p:nvSpPr>
+        <p:spPr>
+          <a:xfrm>
+            <a:off x="457200" y="1371600"/>
+            <a:ext cx="8229600" cy="685800"/>
+          </a:xfrm>
+          <a:prstGeom prst="rect">
+            <a:avLst/>
+          </a:prstGeom>
+          <a:noFill/>
+        </p:spPr>
+        <p:txBody>
+          <a:bodyPr wrap="none">
+            <a:spAutoFit/>
+          </a:bodyPr>
+          <a:lstStyle/>
+          <a:p>
+            <a:pPr>
+              <a:defRPr sz="1100">
+                <a:solidFill>
+                  <a:srgbClr val="333333"/>
+                </a:solidFill>
+              </a:defRPr>
+            </a:pPr>
+            <a:r>
+              <a:t>Demonstrates autonomous AI agent successfully executing complex multi-step cybersecurity penetration testing, showing agents can match professional-level strategic planning and tool orchestration.</a:t>
             </a:r>
           </a:p>
         </p:txBody>
@@ -3657,6 +3946,104 @@
       <p:sp>
         <p:nvSpPr>
           <p:cNvPr id="4" name="TextBox 3"/>
+          <p:cNvSpPr txBox="1"/>
+          <p:nvPr/>
+        </p:nvSpPr>
+        <p:spPr>
+          <a:xfrm>
+            <a:off x="457200" y="2057400"/>
+            <a:ext cx="8229600" cy="685800"/>
+          </a:xfrm>
+          <a:prstGeom prst="rect">
+            <a:avLst/>
+          </a:prstGeom>
+          <a:noFill/>
+        </p:spPr>
+        <p:txBody>
+          <a:bodyPr wrap="none">
+            <a:spAutoFit/>
+          </a:bodyPr>
+          <a:lstStyle/>
+          <a:p>
+            <a:pPr>
+              <a:defRPr sz="800"/>
+            </a:pPr>
+          </a:p>
+        </p:txBody>
+      </p:sp>
+      <p:sp>
+        <p:nvSpPr>
+          <p:cNvPr id="5" name="TextBox 4"/>
+          <p:cNvSpPr txBox="1"/>
+          <p:nvPr/>
+        </p:nvSpPr>
+        <p:spPr>
+          <a:xfrm>
+            <a:off x="457200" y="2743200"/>
+            <a:ext cx="8229600" cy="685800"/>
+          </a:xfrm>
+          <a:prstGeom prst="rect">
+            <a:avLst/>
+          </a:prstGeom>
+          <a:noFill/>
+        </p:spPr>
+        <p:txBody>
+          <a:bodyPr wrap="none">
+            <a:spAutoFit/>
+          </a:bodyPr>
+          <a:lstStyle/>
+          <a:p>
+            <a:pPr>
+              <a:defRPr sz="900" i="1">
+                <a:solidFill>
+                  <a:srgbClr val="666666"/>
+                </a:solidFill>
+              </a:defRPr>
+            </a:pPr>
+            <a:r>
+              <a:t>📍 r/artificial • 205 upvotes • 32 comments</a:t>
+            </a:r>
+          </a:p>
+        </p:txBody>
+      </p:sp>
+      <p:sp>
+        <p:nvSpPr>
+          <p:cNvPr id="6" name="TextBox 5"/>
+          <p:cNvSpPr txBox="1"/>
+          <p:nvPr/>
+        </p:nvSpPr>
+        <p:spPr>
+          <a:xfrm>
+            <a:off x="457200" y="3429000"/>
+            <a:ext cx="8229600" cy="685800"/>
+          </a:xfrm>
+          <a:prstGeom prst="rect">
+            <a:avLst/>
+          </a:prstGeom>
+          <a:noFill/>
+        </p:spPr>
+        <p:txBody>
+          <a:bodyPr wrap="none">
+            <a:spAutoFit/>
+          </a:bodyPr>
+          <a:lstStyle/>
+          <a:p>
+            <a:pPr>
+              <a:defRPr sz="800">
+                <a:solidFill>
+                  <a:srgbClr val="3498DB"/>
+                </a:solidFill>
+              </a:defRPr>
+            </a:pPr>
+            <a:r>
+              <a:t>🔗 https://reddit.com/r/artificial/comments/1pkuaaq/an_ai_ag...</a:t>
+            </a:r>
+          </a:p>
+        </p:txBody>
+      </p:sp>
+      <p:sp>
+        <p:nvSpPr>
+          <p:cNvPr id="7" name="TextBox 6"/>
           <p:cNvSpPr txBox="1"/>
           <p:nvPr/>
         </p:nvSpPr>
@@ -3713,63 +4100,66 @@
       <p:grpSpPr/>
       <p:sp>
         <p:nvSpPr>
-          <p:cNvPr id="2" name="Title 1"/>
-          <p:cNvSpPr>
-            <a:spLocks noGrp="1"/>
-          </p:cNvSpPr>
-          <p:nvPr>
-            <p:ph type="title"/>
-          </p:nvPr>
-        </p:nvSpPr>
-        <p:spPr/>
-        <p:txBody>
-          <a:bodyPr/>
-          <a:lstStyle/>
-          <a:p>
-            <a:r>
-              <a:t>5. Microsoft Scales Back AI Goals Because Almost Nobody Is Using Copilot</a:t>
-            </a:r>
-          </a:p>
-        </p:txBody>
-      </p:sp>
-      <p:sp>
-        <p:nvSpPr>
-          <p:cNvPr id="3" name="Content Placeholder 2"/>
-          <p:cNvSpPr>
-            <a:spLocks noGrp="1"/>
-          </p:cNvSpPr>
-          <p:nvPr>
-            <p:ph idx="1"/>
-          </p:nvPr>
-        </p:nvSpPr>
-        <p:spPr/>
-        <p:txBody>
-          <a:bodyPr/>
-          <a:lstStyle/>
-          <a:p>
-            <a:r>
-              <a:t>Reveals adoption challenges for AI agent assistants in enterprise settings, highlighting</a:t>
-            </a:r>
-          </a:p>
-          <a:p>
-            <a:pPr/>
-            <a:r>
-              <a:t>the gap between agent capabilities and practical workplace integration.</a:t>
-            </a:r>
-          </a:p>
-          <a:p>
-            <a:pPr/>
-          </a:p>
-          <a:p>
-            <a:pPr/>
-            <a:r>
-              <a:t>📍 r/artificial • 265 upvotes • 66 comments</a:t>
-            </a:r>
-          </a:p>
-          <a:p>
-            <a:pPr/>
-            <a:r>
-              <a:t>🔗 https://reddit.com/r/artificial/comments/1pmuboi/microsoft_scales_back_a...</a:t>
+          <p:cNvPr id="2" name="TextBox 1"/>
+          <p:cNvSpPr txBox="1"/>
+          <p:nvPr/>
+        </p:nvSpPr>
+        <p:spPr>
+          <a:xfrm>
+            <a:off x="457200" y="457200"/>
+            <a:ext cx="8229600" cy="685800"/>
+          </a:xfrm>
+          <a:prstGeom prst="rect">
+            <a:avLst/>
+          </a:prstGeom>
+          <a:noFill/>
+        </p:spPr>
+        <p:txBody>
+          <a:bodyPr wrap="none">
+            <a:spAutoFit/>
+          </a:bodyPr>
+          <a:lstStyle/>
+          <a:p>
+            <a:pPr>
+              <a:defRPr sz="3200" b="1"/>
+            </a:pPr>
+            <a:r>
+              <a:t>5. Pete Hegseth Says the Pentagon's New Chatbot Will Make America 'More Lethal'. The Department of War aims to put Google Gemini 'directly into the hands of every American warrior.'</a:t>
+            </a:r>
+          </a:p>
+        </p:txBody>
+      </p:sp>
+      <p:sp>
+        <p:nvSpPr>
+          <p:cNvPr id="3" name="TextBox 2"/>
+          <p:cNvSpPr txBox="1"/>
+          <p:nvPr/>
+        </p:nvSpPr>
+        <p:spPr>
+          <a:xfrm>
+            <a:off x="457200" y="1371600"/>
+            <a:ext cx="8229600" cy="685800"/>
+          </a:xfrm>
+          <a:prstGeom prst="rect">
+            <a:avLst/>
+          </a:prstGeom>
+          <a:noFill/>
+        </p:spPr>
+        <p:txBody>
+          <a:bodyPr wrap="none">
+            <a:spAutoFit/>
+          </a:bodyPr>
+          <a:lstStyle/>
+          <a:p>
+            <a:pPr>
+              <a:defRPr sz="1100">
+                <a:solidFill>
+                  <a:srgbClr val="333333"/>
+                </a:solidFill>
+              </a:defRPr>
+            </a:pPr>
+            <a:r>
+              <a:t>Pentagon's deployment of Google Gemini to military personnel represents large-scale institutional adoption of AI agents for tactical decision support and operational planning.</a:t>
             </a:r>
           </a:p>
         </p:txBody>
@@ -3777,6 +4167,104 @@
       <p:sp>
         <p:nvSpPr>
           <p:cNvPr id="4" name="TextBox 3"/>
+          <p:cNvSpPr txBox="1"/>
+          <p:nvPr/>
+        </p:nvSpPr>
+        <p:spPr>
+          <a:xfrm>
+            <a:off x="457200" y="2057400"/>
+            <a:ext cx="8229600" cy="685800"/>
+          </a:xfrm>
+          <a:prstGeom prst="rect">
+            <a:avLst/>
+          </a:prstGeom>
+          <a:noFill/>
+        </p:spPr>
+        <p:txBody>
+          <a:bodyPr wrap="none">
+            <a:spAutoFit/>
+          </a:bodyPr>
+          <a:lstStyle/>
+          <a:p>
+            <a:pPr>
+              <a:defRPr sz="800"/>
+            </a:pPr>
+          </a:p>
+        </p:txBody>
+      </p:sp>
+      <p:sp>
+        <p:nvSpPr>
+          <p:cNvPr id="5" name="TextBox 4"/>
+          <p:cNvSpPr txBox="1"/>
+          <p:nvPr/>
+        </p:nvSpPr>
+        <p:spPr>
+          <a:xfrm>
+            <a:off x="457200" y="2743200"/>
+            <a:ext cx="8229600" cy="685800"/>
+          </a:xfrm>
+          <a:prstGeom prst="rect">
+            <a:avLst/>
+          </a:prstGeom>
+          <a:noFill/>
+        </p:spPr>
+        <p:txBody>
+          <a:bodyPr wrap="none">
+            <a:spAutoFit/>
+          </a:bodyPr>
+          <a:lstStyle/>
+          <a:p>
+            <a:pPr>
+              <a:defRPr sz="900" i="1">
+                <a:solidFill>
+                  <a:srgbClr val="666666"/>
+                </a:solidFill>
+              </a:defRPr>
+            </a:pPr>
+            <a:r>
+              <a:t>📍 r/artificial • 256 upvotes • 125 comments</a:t>
+            </a:r>
+          </a:p>
+        </p:txBody>
+      </p:sp>
+      <p:sp>
+        <p:nvSpPr>
+          <p:cNvPr id="6" name="TextBox 5"/>
+          <p:cNvSpPr txBox="1"/>
+          <p:nvPr/>
+        </p:nvSpPr>
+        <p:spPr>
+          <a:xfrm>
+            <a:off x="457200" y="3429000"/>
+            <a:ext cx="8229600" cy="685800"/>
+          </a:xfrm>
+          <a:prstGeom prst="rect">
+            <a:avLst/>
+          </a:prstGeom>
+          <a:noFill/>
+        </p:spPr>
+        <p:txBody>
+          <a:bodyPr wrap="none">
+            <a:spAutoFit/>
+          </a:bodyPr>
+          <a:lstStyle/>
+          <a:p>
+            <a:pPr>
+              <a:defRPr sz="800">
+                <a:solidFill>
+                  <a:srgbClr val="3498DB"/>
+                </a:solidFill>
+              </a:defRPr>
+            </a:pPr>
+            <a:r>
+              <a:t>🔗 https://reddit.com/r/artificial/comments/1piors1/pete_heg...</a:t>
+            </a:r>
+          </a:p>
+        </p:txBody>
+      </p:sp>
+      <p:sp>
+        <p:nvSpPr>
+          <p:cNvPr id="7" name="TextBox 6"/>
           <p:cNvSpPr txBox="1"/>
           <p:nvPr/>
         </p:nvSpPr>
@@ -3833,19 +4321,29 @@
       <p:grpSpPr/>
       <p:sp>
         <p:nvSpPr>
-          <p:cNvPr id="2" name="Title 1"/>
-          <p:cNvSpPr>
-            <a:spLocks noGrp="1"/>
-          </p:cNvSpPr>
-          <p:nvPr>
-            <p:ph type="title"/>
-          </p:nvPr>
-        </p:nvSpPr>
-        <p:spPr/>
-        <p:txBody>
-          <a:bodyPr/>
-          <a:lstStyle/>
-          <a:p>
+          <p:cNvPr id="2" name="TextBox 1"/>
+          <p:cNvSpPr txBox="1"/>
+          <p:nvPr/>
+        </p:nvSpPr>
+        <p:spPr>
+          <a:xfrm>
+            <a:off x="457200" y="457200"/>
+            <a:ext cx="8229600" cy="685800"/>
+          </a:xfrm>
+          <a:prstGeom prst="rect">
+            <a:avLst/>
+          </a:prstGeom>
+          <a:noFill/>
+        </p:spPr>
+        <p:txBody>
+          <a:bodyPr wrap="none">
+            <a:spAutoFit/>
+          </a:bodyPr>
+          <a:lstStyle/>
+          <a:p>
+            <a:pPr>
+              <a:defRPr sz="3200" b="1"/>
+            </a:pPr>
             <a:r>
               <a:t>🛠️ Tools &amp; Frameworks</a:t>
             </a:r>
@@ -3854,28 +4352,96 @@
       </p:sp>
       <p:sp>
         <p:nvSpPr>
-          <p:cNvPr id="3" name="Content Placeholder 2"/>
-          <p:cNvSpPr>
-            <a:spLocks noGrp="1"/>
-          </p:cNvSpPr>
-          <p:nvPr>
-            <p:ph idx="1"/>
-          </p:nvPr>
-        </p:nvSpPr>
-        <p:spPr/>
-        <p:txBody>
-          <a:bodyPr/>
-          <a:lstStyle/>
-          <a:p>
+          <p:cNvPr id="3" name="TextBox 2"/>
+          <p:cNvSpPr txBox="1"/>
+          <p:nvPr/>
+        </p:nvSpPr>
+        <p:spPr>
+          <a:xfrm>
+            <a:off x="457200" y="1371600"/>
+            <a:ext cx="8229600" cy="685800"/>
+          </a:xfrm>
+          <a:prstGeom prst="rect">
+            <a:avLst/>
+          </a:prstGeom>
+          <a:noFill/>
+        </p:spPr>
+        <p:txBody>
+          <a:bodyPr wrap="none">
+            <a:spAutoFit/>
+          </a:bodyPr>
+          <a:lstStyle/>
+          <a:p>
+            <a:pPr>
+              <a:defRPr sz="1800" b="1">
+                <a:solidFill>
+                  <a:srgbClr val="FFFFFF"/>
+                </a:solidFill>
+              </a:defRPr>
+            </a:pPr>
             <a:r>
               <a:t>4 key updates this week</a:t>
             </a:r>
           </a:p>
-          <a:p>
-            <a:pPr/>
-          </a:p>
-          <a:p>
-            <a:pPr/>
+        </p:txBody>
+      </p:sp>
+      <p:sp>
+        <p:nvSpPr>
+          <p:cNvPr id="4" name="TextBox 3"/>
+          <p:cNvSpPr txBox="1"/>
+          <p:nvPr/>
+        </p:nvSpPr>
+        <p:spPr>
+          <a:xfrm>
+            <a:off x="457200" y="2057400"/>
+            <a:ext cx="8229600" cy="685800"/>
+          </a:xfrm>
+          <a:prstGeom prst="rect">
+            <a:avLst/>
+          </a:prstGeom>
+          <a:noFill/>
+        </p:spPr>
+        <p:txBody>
+          <a:bodyPr wrap="none">
+            <a:spAutoFit/>
+          </a:bodyPr>
+          <a:lstStyle/>
+          <a:p>
+            <a:pPr>
+              <a:defRPr sz="1200"/>
+            </a:pPr>
+          </a:p>
+        </p:txBody>
+      </p:sp>
+      <p:sp>
+        <p:nvSpPr>
+          <p:cNvPr id="5" name="TextBox 4"/>
+          <p:cNvSpPr txBox="1"/>
+          <p:nvPr/>
+        </p:nvSpPr>
+        <p:spPr>
+          <a:xfrm>
+            <a:off x="457200" y="2743200"/>
+            <a:ext cx="8229600" cy="685800"/>
+          </a:xfrm>
+          <a:prstGeom prst="rect">
+            <a:avLst/>
+          </a:prstGeom>
+          <a:noFill/>
+        </p:spPr>
+        <p:txBody>
+          <a:bodyPr wrap="none">
+            <a:spAutoFit/>
+          </a:bodyPr>
+          <a:lstStyle/>
+          <a:p>
+            <a:pPr>
+              <a:defRPr sz="1400" i="1">
+                <a:solidFill>
+                  <a:srgbClr val="FFFFFF"/>
+                </a:solidFill>
+              </a:defRPr>
+            </a:pPr>
             <a:r>
               <a:t>→ Swipe to explore</a:t>
             </a:r>
@@ -3884,7 +4450,7 @@
       </p:sp>
       <p:sp>
         <p:nvSpPr>
-          <p:cNvPr id="4" name="TextBox 3"/>
+          <p:cNvPr id="6" name="TextBox 5"/>
           <p:cNvSpPr txBox="1"/>
           <p:nvPr/>
         </p:nvSpPr>
@@ -3941,19 +4507,29 @@
       <p:grpSpPr/>
       <p:sp>
         <p:nvSpPr>
-          <p:cNvPr id="2" name="Title 1"/>
-          <p:cNvSpPr>
-            <a:spLocks noGrp="1"/>
-          </p:cNvSpPr>
-          <p:nvPr>
-            <p:ph type="title"/>
-          </p:nvPr>
-        </p:nvSpPr>
-        <p:spPr/>
-        <p:txBody>
-          <a:bodyPr/>
-          <a:lstStyle/>
-          <a:p>
+          <p:cNvPr id="2" name="TextBox 1"/>
+          <p:cNvSpPr txBox="1"/>
+          <p:nvPr/>
+        </p:nvSpPr>
+        <p:spPr>
+          <a:xfrm>
+            <a:off x="457200" y="457200"/>
+            <a:ext cx="8229600" cy="685800"/>
+          </a:xfrm>
+          <a:prstGeom prst="rect">
+            <a:avLst/>
+          </a:prstGeom>
+          <a:noFill/>
+        </p:spPr>
+        <p:txBody>
+          <a:bodyPr wrap="none">
+            <a:spAutoFit/>
+          </a:bodyPr>
+          <a:lstStyle/>
+          <a:p>
+            <a:pPr>
+              <a:defRPr sz="3200" b="1"/>
+            </a:pPr>
             <a:r>
               <a:t>1. Introducing: Devstral 2 and Mistral Vibe CLI</a:t>
             </a:r>
@@ -3962,42 +4538,35 @@
       </p:sp>
       <p:sp>
         <p:nvSpPr>
-          <p:cNvPr id="3" name="Content Placeholder 2"/>
-          <p:cNvSpPr>
-            <a:spLocks noGrp="1"/>
-          </p:cNvSpPr>
-          <p:nvPr>
-            <p:ph idx="1"/>
-          </p:nvPr>
-        </p:nvSpPr>
-        <p:spPr/>
-        <p:txBody>
-          <a:bodyPr/>
-          <a:lstStyle/>
-          <a:p>
-            <a:r>
-              <a:t>Mistral releases new coding-focused model with CLI interface, expanding the ecosystem of</a:t>
-            </a:r>
-          </a:p>
-          <a:p>
-            <a:pPr/>
-            <a:r>
-              <a:t>developer-oriented agent tools with open-source alternatives.</a:t>
-            </a:r>
-          </a:p>
-          <a:p>
-            <a:pPr/>
-          </a:p>
-          <a:p>
-            <a:pPr/>
-            <a:r>
-              <a:t>📍 r/LocalLLaMA • 687 upvotes • 218 comments</a:t>
-            </a:r>
-          </a:p>
-          <a:p>
-            <a:pPr/>
-            <a:r>
-              <a:t>🔗 https://reddit.com/r/LocalLLaMA/comments/1pi9q3t/introducing_devstral_2_...</a:t>
+          <p:cNvPr id="3" name="TextBox 2"/>
+          <p:cNvSpPr txBox="1"/>
+          <p:nvPr/>
+        </p:nvSpPr>
+        <p:spPr>
+          <a:xfrm>
+            <a:off x="457200" y="1371600"/>
+            <a:ext cx="8229600" cy="685800"/>
+          </a:xfrm>
+          <a:prstGeom prst="rect">
+            <a:avLst/>
+          </a:prstGeom>
+          <a:noFill/>
+        </p:spPr>
+        <p:txBody>
+          <a:bodyPr wrap="none">
+            <a:spAutoFit/>
+          </a:bodyPr>
+          <a:lstStyle/>
+          <a:p>
+            <a:pPr>
+              <a:defRPr sz="1100">
+                <a:solidFill>
+                  <a:srgbClr val="333333"/>
+                </a:solidFill>
+              </a:defRPr>
+            </a:pPr>
+            <a:r>
+              <a:t>Mistral launches Devstral 2 with CLI interface for agentic coding workflows, joining the wave of command-line agent frameworks for developer automation.</a:t>
             </a:r>
           </a:p>
         </p:txBody>
@@ -4005,6 +4574,104 @@
       <p:sp>
         <p:nvSpPr>
           <p:cNvPr id="4" name="TextBox 3"/>
+          <p:cNvSpPr txBox="1"/>
+          <p:nvPr/>
+        </p:nvSpPr>
+        <p:spPr>
+          <a:xfrm>
+            <a:off x="457200" y="2057400"/>
+            <a:ext cx="8229600" cy="685800"/>
+          </a:xfrm>
+          <a:prstGeom prst="rect">
+            <a:avLst/>
+          </a:prstGeom>
+          <a:noFill/>
+        </p:spPr>
+        <p:txBody>
+          <a:bodyPr wrap="none">
+            <a:spAutoFit/>
+          </a:bodyPr>
+          <a:lstStyle/>
+          <a:p>
+            <a:pPr>
+              <a:defRPr sz="800"/>
+            </a:pPr>
+          </a:p>
+        </p:txBody>
+      </p:sp>
+      <p:sp>
+        <p:nvSpPr>
+          <p:cNvPr id="5" name="TextBox 4"/>
+          <p:cNvSpPr txBox="1"/>
+          <p:nvPr/>
+        </p:nvSpPr>
+        <p:spPr>
+          <a:xfrm>
+            <a:off x="457200" y="2743200"/>
+            <a:ext cx="8229600" cy="685800"/>
+          </a:xfrm>
+          <a:prstGeom prst="rect">
+            <a:avLst/>
+          </a:prstGeom>
+          <a:noFill/>
+        </p:spPr>
+        <p:txBody>
+          <a:bodyPr wrap="none">
+            <a:spAutoFit/>
+          </a:bodyPr>
+          <a:lstStyle/>
+          <a:p>
+            <a:pPr>
+              <a:defRPr sz="900" i="1">
+                <a:solidFill>
+                  <a:srgbClr val="666666"/>
+                </a:solidFill>
+              </a:defRPr>
+            </a:pPr>
+            <a:r>
+              <a:t>📍 r/LocalLLaMA • 692 upvotes • 218 comments</a:t>
+            </a:r>
+          </a:p>
+        </p:txBody>
+      </p:sp>
+      <p:sp>
+        <p:nvSpPr>
+          <p:cNvPr id="6" name="TextBox 5"/>
+          <p:cNvSpPr txBox="1"/>
+          <p:nvPr/>
+        </p:nvSpPr>
+        <p:spPr>
+          <a:xfrm>
+            <a:off x="457200" y="3429000"/>
+            <a:ext cx="8229600" cy="685800"/>
+          </a:xfrm>
+          <a:prstGeom prst="rect">
+            <a:avLst/>
+          </a:prstGeom>
+          <a:noFill/>
+        </p:spPr>
+        <p:txBody>
+          <a:bodyPr wrap="none">
+            <a:spAutoFit/>
+          </a:bodyPr>
+          <a:lstStyle/>
+          <a:p>
+            <a:pPr>
+              <a:defRPr sz="800">
+                <a:solidFill>
+                  <a:srgbClr val="3498DB"/>
+                </a:solidFill>
+              </a:defRPr>
+            </a:pPr>
+            <a:r>
+              <a:t>🔗 https://reddit.com/r/LocalLLaMA/comments/1pi9q3t/introduc...</a:t>
+            </a:r>
+          </a:p>
+        </p:txBody>
+      </p:sp>
+      <p:sp>
+        <p:nvSpPr>
+          <p:cNvPr id="7" name="TextBox 6"/>
           <p:cNvSpPr txBox="1"/>
           <p:nvPr/>
         </p:nvSpPr>
@@ -4061,63 +4728,66 @@
       <p:grpSpPr/>
       <p:sp>
         <p:nvSpPr>
-          <p:cNvPr id="2" name="Title 1"/>
-          <p:cNvSpPr>
-            <a:spLocks noGrp="1"/>
-          </p:cNvSpPr>
-          <p:nvPr>
-            <p:ph type="title"/>
-          </p:nvPr>
-        </p:nvSpPr>
-        <p:spPr/>
-        <p:txBody>
-          <a:bodyPr/>
-          <a:lstStyle/>
-          <a:p>
-            <a:r>
-              <a:t>2. OpenAI Skills in ChatGPT and Codex CLI</a:t>
-            </a:r>
-          </a:p>
-        </p:txBody>
-      </p:sp>
-      <p:sp>
-        <p:nvSpPr>
-          <p:cNvPr id="3" name="Content Placeholder 2"/>
-          <p:cNvSpPr>
-            <a:spLocks noGrp="1"/>
-          </p:cNvSpPr>
-          <p:nvPr>
-            <p:ph idx="1"/>
-          </p:nvPr>
-        </p:nvSpPr>
-        <p:spPr/>
-        <p:txBody>
-          <a:bodyPr/>
-          <a:lstStyle/>
-          <a:p>
-            <a:r>
-              <a:t>Introduction of modular 'skills' system enables composable agent capabilities and tool</a:t>
-            </a:r>
-          </a:p>
-          <a:p>
-            <a:pPr/>
-            <a:r>
-              <a:t>integration, representing architectural shift toward more flexible agent frameworks.</a:t>
-            </a:r>
-          </a:p>
-          <a:p>
-            <a:pPr/>
-          </a:p>
-          <a:p>
-            <a:pPr/>
-            <a:r>
-              <a:t>📍 Hacker News • 568 points • 313 comments</a:t>
-            </a:r>
-          </a:p>
-          <a:p>
-            <a:pPr/>
-            <a:r>
-              <a:t>🔗 https://simonwillison.net/2025/Dec/12/openai-skills/</a:t>
+          <p:cNvPr id="2" name="TextBox 1"/>
+          <p:cNvSpPr txBox="1"/>
+          <p:nvPr/>
+        </p:nvSpPr>
+        <p:spPr>
+          <a:xfrm>
+            <a:off x="457200" y="457200"/>
+            <a:ext cx="8229600" cy="685800"/>
+          </a:xfrm>
+          <a:prstGeom prst="rect">
+            <a:avLst/>
+          </a:prstGeom>
+          <a:noFill/>
+        </p:spPr>
+        <p:txBody>
+          <a:bodyPr wrap="none">
+            <a:spAutoFit/>
+          </a:bodyPr>
+          <a:lstStyle/>
+          <a:p>
+            <a:pPr>
+              <a:defRPr sz="3200" b="1"/>
+            </a:pPr>
+            <a:r>
+              <a:t>2. You can now train LLMs 3x faster with 30% less memory! (&lt;3.9GB VRAM)</a:t>
+            </a:r>
+          </a:p>
+        </p:txBody>
+      </p:sp>
+      <p:sp>
+        <p:nvSpPr>
+          <p:cNvPr id="3" name="TextBox 2"/>
+          <p:cNvSpPr txBox="1"/>
+          <p:nvPr/>
+        </p:nvSpPr>
+        <p:spPr>
+          <a:xfrm>
+            <a:off x="457200" y="1371600"/>
+            <a:ext cx="8229600" cy="685800"/>
+          </a:xfrm>
+          <a:prstGeom prst="rect">
+            <a:avLst/>
+          </a:prstGeom>
+          <a:noFill/>
+        </p:spPr>
+        <p:txBody>
+          <a:bodyPr wrap="none">
+            <a:spAutoFit/>
+          </a:bodyPr>
+          <a:lstStyle/>
+          <a:p>
+            <a:pPr>
+              <a:defRPr sz="1100">
+                <a:solidFill>
+                  <a:srgbClr val="333333"/>
+                </a:solidFill>
+              </a:defRPr>
+            </a:pPr>
+            <a:r>
+              <a:t>Memory optimization breakthrough enables local training of agent models on consumer hardware, democratizing development of custom agentic systems.</a:t>
             </a:r>
           </a:p>
         </p:txBody>
@@ -4125,6 +4795,104 @@
       <p:sp>
         <p:nvSpPr>
           <p:cNvPr id="4" name="TextBox 3"/>
+          <p:cNvSpPr txBox="1"/>
+          <p:nvPr/>
+        </p:nvSpPr>
+        <p:spPr>
+          <a:xfrm>
+            <a:off x="457200" y="2057400"/>
+            <a:ext cx="8229600" cy="685800"/>
+          </a:xfrm>
+          <a:prstGeom prst="rect">
+            <a:avLst/>
+          </a:prstGeom>
+          <a:noFill/>
+        </p:spPr>
+        <p:txBody>
+          <a:bodyPr wrap="none">
+            <a:spAutoFit/>
+          </a:bodyPr>
+          <a:lstStyle/>
+          <a:p>
+            <a:pPr>
+              <a:defRPr sz="800"/>
+            </a:pPr>
+          </a:p>
+        </p:txBody>
+      </p:sp>
+      <p:sp>
+        <p:nvSpPr>
+          <p:cNvPr id="5" name="TextBox 4"/>
+          <p:cNvSpPr txBox="1"/>
+          <p:nvPr/>
+        </p:nvSpPr>
+        <p:spPr>
+          <a:xfrm>
+            <a:off x="457200" y="2743200"/>
+            <a:ext cx="8229600" cy="685800"/>
+          </a:xfrm>
+          <a:prstGeom prst="rect">
+            <a:avLst/>
+          </a:prstGeom>
+          <a:noFill/>
+        </p:spPr>
+        <p:txBody>
+          <a:bodyPr wrap="none">
+            <a:spAutoFit/>
+          </a:bodyPr>
+          <a:lstStyle/>
+          <a:p>
+            <a:pPr>
+              <a:defRPr sz="900" i="1">
+                <a:solidFill>
+                  <a:srgbClr val="666666"/>
+                </a:solidFill>
+              </a:defRPr>
+            </a:pPr>
+            <a:r>
+              <a:t>📍 r/LocalLLaMA • 1027 upvotes • 114 comments</a:t>
+            </a:r>
+          </a:p>
+        </p:txBody>
+      </p:sp>
+      <p:sp>
+        <p:nvSpPr>
+          <p:cNvPr id="6" name="TextBox 5"/>
+          <p:cNvSpPr txBox="1"/>
+          <p:nvPr/>
+        </p:nvSpPr>
+        <p:spPr>
+          <a:xfrm>
+            <a:off x="457200" y="3429000"/>
+            <a:ext cx="8229600" cy="685800"/>
+          </a:xfrm>
+          <a:prstGeom prst="rect">
+            <a:avLst/>
+          </a:prstGeom>
+          <a:noFill/>
+        </p:spPr>
+        <p:txBody>
+          <a:bodyPr wrap="none">
+            <a:spAutoFit/>
+          </a:bodyPr>
+          <a:lstStyle/>
+          <a:p>
+            <a:pPr>
+              <a:defRPr sz="800">
+                <a:solidFill>
+                  <a:srgbClr val="3498DB"/>
+                </a:solidFill>
+              </a:defRPr>
+            </a:pPr>
+            <a:r>
+              <a:t>🔗 https://reddit.com/r/LocalLLaMA/comments/1pj51tu/you_can_...</a:t>
+            </a:r>
+          </a:p>
+        </p:txBody>
+      </p:sp>
+      <p:sp>
+        <p:nvSpPr>
+          <p:cNvPr id="7" name="TextBox 6"/>
           <p:cNvSpPr txBox="1"/>
           <p:nvPr/>
         </p:nvSpPr>
@@ -4181,63 +4949,66 @@
       <p:grpSpPr/>
       <p:sp>
         <p:nvSpPr>
-          <p:cNvPr id="2" name="Title 1"/>
-          <p:cNvSpPr>
-            <a:spLocks noGrp="1"/>
-          </p:cNvSpPr>
-          <p:nvPr>
-            <p:ph type="title"/>
-          </p:nvPr>
-        </p:nvSpPr>
-        <p:spPr/>
-        <p:txBody>
-          <a:bodyPr/>
-          <a:lstStyle/>
-          <a:p>
-            <a:r>
-              <a:t>3. You can now train LLMs 3x faster with 30% less memory! (&lt;3.9GB VRAM)</a:t>
-            </a:r>
-          </a:p>
-        </p:txBody>
-      </p:sp>
-      <p:sp>
-        <p:nvSpPr>
-          <p:cNvPr id="3" name="Content Placeholder 2"/>
-          <p:cNvSpPr>
-            <a:spLocks noGrp="1"/>
-          </p:cNvSpPr>
-          <p:nvPr>
-            <p:ph idx="1"/>
-          </p:nvPr>
-        </p:nvSpPr>
-        <p:spPr/>
-        <p:txBody>
-          <a:bodyPr/>
-          <a:lstStyle/>
-          <a:p>
-            <a:r>
-              <a:t>Major efficiency breakthrough enabling local training and fine-tuning of agent models on</a:t>
-            </a:r>
-          </a:p>
-          <a:p>
-            <a:pPr/>
-            <a:r>
-              <a:t>consumer hardware, democratizing agent development.</a:t>
-            </a:r>
-          </a:p>
-          <a:p>
-            <a:pPr/>
-          </a:p>
-          <a:p>
-            <a:pPr/>
-            <a:r>
-              <a:t>📍 r/LocalLLaMA • 1028 upvotes • 114 comments</a:t>
-            </a:r>
-          </a:p>
-          <a:p>
-            <a:pPr/>
-            <a:r>
-              <a:t>🔗 https://reddit.com/r/LocalLLaMA/comments/1pj51tu/you_can_now_train_llms_...</a:t>
+          <p:cNvPr id="2" name="TextBox 1"/>
+          <p:cNvSpPr txBox="1"/>
+          <p:nvPr/>
+        </p:nvSpPr>
+        <p:spPr>
+          <a:xfrm>
+            <a:off x="457200" y="457200"/>
+            <a:ext cx="8229600" cy="685800"/>
+          </a:xfrm>
+          <a:prstGeom prst="rect">
+            <a:avLst/>
+          </a:prstGeom>
+          <a:noFill/>
+        </p:spPr>
+        <p:txBody>
+          <a:bodyPr wrap="none">
+            <a:spAutoFit/>
+          </a:bodyPr>
+          <a:lstStyle/>
+          <a:p>
+            <a:pPr>
+              <a:defRPr sz="3200" b="1"/>
+            </a:pPr>
+            <a:r>
+              <a:t>3. SUMFORU: An LLM-Based Review Summarization Framework for Personalized Purchase Decision Support</a:t>
+            </a:r>
+          </a:p>
+        </p:txBody>
+      </p:sp>
+      <p:sp>
+        <p:nvSpPr>
+          <p:cNvPr id="3" name="TextBox 2"/>
+          <p:cNvSpPr txBox="1"/>
+          <p:nvPr/>
+        </p:nvSpPr>
+        <p:spPr>
+          <a:xfrm>
+            <a:off x="457200" y="1371600"/>
+            <a:ext cx="8229600" cy="685800"/>
+          </a:xfrm>
+          <a:prstGeom prst="rect">
+            <a:avLst/>
+          </a:prstGeom>
+          <a:noFill/>
+        </p:spPr>
+        <p:txBody>
+          <a:bodyPr wrap="none">
+            <a:spAutoFit/>
+          </a:bodyPr>
+          <a:lstStyle/>
+          <a:p>
+            <a:pPr>
+              <a:defRPr sz="1100">
+                <a:solidFill>
+                  <a:srgbClr val="333333"/>
+                </a:solidFill>
+              </a:defRPr>
+            </a:pPr>
+            <a:r>
+              <a:t>Framework for personalized decision-support agents that aggregate information and reason about user preferences, demonstrating practical agentic reasoning for consumer applications.</a:t>
             </a:r>
           </a:p>
         </p:txBody>
@@ -4245,6 +5016,104 @@
       <p:sp>
         <p:nvSpPr>
           <p:cNvPr id="4" name="TextBox 3"/>
+          <p:cNvSpPr txBox="1"/>
+          <p:nvPr/>
+        </p:nvSpPr>
+        <p:spPr>
+          <a:xfrm>
+            <a:off x="457200" y="2057400"/>
+            <a:ext cx="8229600" cy="685800"/>
+          </a:xfrm>
+          <a:prstGeom prst="rect">
+            <a:avLst/>
+          </a:prstGeom>
+          <a:noFill/>
+        </p:spPr>
+        <p:txBody>
+          <a:bodyPr wrap="none">
+            <a:spAutoFit/>
+          </a:bodyPr>
+          <a:lstStyle/>
+          <a:p>
+            <a:pPr>
+              <a:defRPr sz="800"/>
+            </a:pPr>
+          </a:p>
+        </p:txBody>
+      </p:sp>
+      <p:sp>
+        <p:nvSpPr>
+          <p:cNvPr id="5" name="TextBox 4"/>
+          <p:cNvSpPr txBox="1"/>
+          <p:nvPr/>
+        </p:nvSpPr>
+        <p:spPr>
+          <a:xfrm>
+            <a:off x="457200" y="2743200"/>
+            <a:ext cx="8229600" cy="685800"/>
+          </a:xfrm>
+          <a:prstGeom prst="rect">
+            <a:avLst/>
+          </a:prstGeom>
+          <a:noFill/>
+        </p:spPr>
+        <p:txBody>
+          <a:bodyPr wrap="none">
+            <a:spAutoFit/>
+          </a:bodyPr>
+          <a:lstStyle/>
+          <a:p>
+            <a:pPr>
+              <a:defRPr sz="900" i="1">
+                <a:solidFill>
+                  <a:srgbClr val="666666"/>
+                </a:solidFill>
+              </a:defRPr>
+            </a:pPr>
+            <a:r>
+              <a:t>📍 arXiv • Yuming Feng, Xinrui Jiang</a:t>
+            </a:r>
+          </a:p>
+        </p:txBody>
+      </p:sp>
+      <p:sp>
+        <p:nvSpPr>
+          <p:cNvPr id="6" name="TextBox 5"/>
+          <p:cNvSpPr txBox="1"/>
+          <p:nvPr/>
+        </p:nvSpPr>
+        <p:spPr>
+          <a:xfrm>
+            <a:off x="457200" y="3429000"/>
+            <a:ext cx="8229600" cy="685800"/>
+          </a:xfrm>
+          <a:prstGeom prst="rect">
+            <a:avLst/>
+          </a:prstGeom>
+          <a:noFill/>
+        </p:spPr>
+        <p:txBody>
+          <a:bodyPr wrap="none">
+            <a:spAutoFit/>
+          </a:bodyPr>
+          <a:lstStyle/>
+          <a:p>
+            <a:pPr>
+              <a:defRPr sz="800">
+                <a:solidFill>
+                  <a:srgbClr val="3498DB"/>
+                </a:solidFill>
+              </a:defRPr>
+            </a:pPr>
+            <a:r>
+              <a:t>🔗 https://arxiv.org/abs/2512.11755v1</a:t>
+            </a:r>
+          </a:p>
+        </p:txBody>
+      </p:sp>
+      <p:sp>
+        <p:nvSpPr>
+          <p:cNvPr id="7" name="TextBox 6"/>
           <p:cNvSpPr txBox="1"/>
           <p:nvPr/>
         </p:nvSpPr>
@@ -4301,63 +5170,66 @@
       <p:grpSpPr/>
       <p:sp>
         <p:nvSpPr>
-          <p:cNvPr id="2" name="Title 1"/>
-          <p:cNvSpPr>
-            <a:spLocks noGrp="1"/>
-          </p:cNvSpPr>
-          <p:nvPr>
-            <p:ph type="title"/>
-          </p:nvPr>
-        </p:nvSpPr>
-        <p:spPr/>
-        <p:txBody>
-          <a:bodyPr/>
-          <a:lstStyle/>
-          <a:p>
-            <a:r>
-              <a:t>4. Claude CLI Tool</a:t>
-            </a:r>
-          </a:p>
-        </p:txBody>
-      </p:sp>
-      <p:sp>
-        <p:nvSpPr>
-          <p:cNvPr id="3" name="Content Placeholder 2"/>
-          <p:cNvSpPr>
-            <a:spLocks noGrp="1"/>
-          </p:cNvSpPr>
-          <p:nvPr>
-            <p:ph idx="1"/>
-          </p:nvPr>
-        </p:nvSpPr>
-        <p:spPr/>
-        <p:txBody>
-          <a:bodyPr/>
-          <a:lstStyle/>
-          <a:p>
-            <a:r>
-              <a:t>Despite safety incident, represents growing trend of CLI-based agent frameworks for</a:t>
-            </a:r>
-          </a:p>
-          <a:p>
-            <a:pPr/>
-            <a:r>
-              <a:t>developer workflows, highlighting both potential and risks of tool-using agents.</a:t>
-            </a:r>
-          </a:p>
-          <a:p>
-            <a:pPr/>
-          </a:p>
-          <a:p>
-            <a:pPr/>
-            <a:r>
-              <a:t>📍 Hacker News • 220 points • 179 comments</a:t>
-            </a:r>
-          </a:p>
-          <a:p>
-            <a:pPr/>
-            <a:r>
-              <a:t>🔗 https://old.reddit.com/r/ClaudeAI/comments/1pgxckk/claude_cli_deleted_my...</a:t>
+          <p:cNvPr id="2" name="TextBox 1"/>
+          <p:cNvSpPr txBox="1"/>
+          <p:nvPr/>
+        </p:nvSpPr>
+        <p:spPr>
+          <a:xfrm>
+            <a:off x="457200" y="457200"/>
+            <a:ext cx="8229600" cy="685800"/>
+          </a:xfrm>
+          <a:prstGeom prst="rect">
+            <a:avLst/>
+          </a:prstGeom>
+          <a:noFill/>
+        </p:spPr>
+        <p:txBody>
+          <a:bodyPr wrap="none">
+            <a:spAutoFit/>
+          </a:bodyPr>
+          <a:lstStyle/>
+          <a:p>
+            <a:pPr>
+              <a:defRPr sz="3200" b="1"/>
+            </a:pPr>
+            <a:r>
+              <a:t>4. 8x RTX Pro 6000 server complete</a:t>
+            </a:r>
+          </a:p>
+        </p:txBody>
+      </p:sp>
+      <p:sp>
+        <p:nvSpPr>
+          <p:cNvPr id="3" name="TextBox 2"/>
+          <p:cNvSpPr txBox="1"/>
+          <p:nvPr/>
+        </p:nvSpPr>
+        <p:spPr>
+          <a:xfrm>
+            <a:off x="457200" y="1371600"/>
+            <a:ext cx="8229600" cy="685800"/>
+          </a:xfrm>
+          <a:prstGeom prst="rect">
+            <a:avLst/>
+          </a:prstGeom>
+          <a:noFill/>
+        </p:spPr>
+        <p:txBody>
+          <a:bodyPr wrap="none">
+            <a:spAutoFit/>
+          </a:bodyPr>
+          <a:lstStyle/>
+          <a:p>
+            <a:pPr>
+              <a:defRPr sz="1100">
+                <a:solidFill>
+                  <a:srgbClr val="333333"/>
+                </a:solidFill>
+              </a:defRPr>
+            </a:pPr>
+            <a:r>
+              <a:t>Community build showcasing infrastructure for running multi-agent systems and large agentic models locally, reflecting growing interest in self-hosted agent deployments.</a:t>
             </a:r>
           </a:p>
         </p:txBody>
@@ -4365,6 +5237,104 @@
       <p:sp>
         <p:nvSpPr>
           <p:cNvPr id="4" name="TextBox 3"/>
+          <p:cNvSpPr txBox="1"/>
+          <p:nvPr/>
+        </p:nvSpPr>
+        <p:spPr>
+          <a:xfrm>
+            <a:off x="457200" y="2057400"/>
+            <a:ext cx="8229600" cy="685800"/>
+          </a:xfrm>
+          <a:prstGeom prst="rect">
+            <a:avLst/>
+          </a:prstGeom>
+          <a:noFill/>
+        </p:spPr>
+        <p:txBody>
+          <a:bodyPr wrap="none">
+            <a:spAutoFit/>
+          </a:bodyPr>
+          <a:lstStyle/>
+          <a:p>
+            <a:pPr>
+              <a:defRPr sz="800"/>
+            </a:pPr>
+          </a:p>
+        </p:txBody>
+      </p:sp>
+      <p:sp>
+        <p:nvSpPr>
+          <p:cNvPr id="5" name="TextBox 4"/>
+          <p:cNvSpPr txBox="1"/>
+          <p:nvPr/>
+        </p:nvSpPr>
+        <p:spPr>
+          <a:xfrm>
+            <a:off x="457200" y="2743200"/>
+            <a:ext cx="8229600" cy="685800"/>
+          </a:xfrm>
+          <a:prstGeom prst="rect">
+            <a:avLst/>
+          </a:prstGeom>
+          <a:noFill/>
+        </p:spPr>
+        <p:txBody>
+          <a:bodyPr wrap="none">
+            <a:spAutoFit/>
+          </a:bodyPr>
+          <a:lstStyle/>
+          <a:p>
+            <a:pPr>
+              <a:defRPr sz="900" i="1">
+                <a:solidFill>
+                  <a:srgbClr val="666666"/>
+                </a:solidFill>
+              </a:defRPr>
+            </a:pPr>
+            <a:r>
+              <a:t>📍 r/LocalLLaMA • 607 upvotes • 264 comments</a:t>
+            </a:r>
+          </a:p>
+        </p:txBody>
+      </p:sp>
+      <p:sp>
+        <p:nvSpPr>
+          <p:cNvPr id="6" name="TextBox 5"/>
+          <p:cNvSpPr txBox="1"/>
+          <p:nvPr/>
+        </p:nvSpPr>
+        <p:spPr>
+          <a:xfrm>
+            <a:off x="457200" y="3429000"/>
+            <a:ext cx="8229600" cy="685800"/>
+          </a:xfrm>
+          <a:prstGeom prst="rect">
+            <a:avLst/>
+          </a:prstGeom>
+          <a:noFill/>
+        </p:spPr>
+        <p:txBody>
+          <a:bodyPr wrap="none">
+            <a:spAutoFit/>
+          </a:bodyPr>
+          <a:lstStyle/>
+          <a:p>
+            <a:pPr>
+              <a:defRPr sz="800">
+                <a:solidFill>
+                  <a:srgbClr val="3498DB"/>
+                </a:solidFill>
+              </a:defRPr>
+            </a:pPr>
+            <a:r>
+              <a:t>🔗 https://reddit.com/r/LocalLLaMA/comments/1plwgun/8x_rtx_p...</a:t>
+            </a:r>
+          </a:p>
+        </p:txBody>
+      </p:sp>
+      <p:sp>
+        <p:nvSpPr>
+          <p:cNvPr id="7" name="TextBox 6"/>
           <p:cNvSpPr txBox="1"/>
           <p:nvPr/>
         </p:nvSpPr>
@@ -4421,19 +5391,29 @@
       <p:grpSpPr/>
       <p:sp>
         <p:nvSpPr>
-          <p:cNvPr id="2" name="Title 1"/>
-          <p:cNvSpPr>
-            <a:spLocks noGrp="1"/>
-          </p:cNvSpPr>
-          <p:nvPr>
-            <p:ph type="title"/>
-          </p:nvPr>
-        </p:nvSpPr>
-        <p:spPr/>
-        <p:txBody>
-          <a:bodyPr/>
-          <a:lstStyle/>
-          <a:p>
+          <p:cNvPr id="2" name="TextBox 1"/>
+          <p:cNvSpPr txBox="1"/>
+          <p:nvPr/>
+        </p:nvSpPr>
+        <p:spPr>
+          <a:xfrm>
+            <a:off x="457200" y="457200"/>
+            <a:ext cx="8229600" cy="685800"/>
+          </a:xfrm>
+          <a:prstGeom prst="rect">
+            <a:avLst/>
+          </a:prstGeom>
+          <a:noFill/>
+        </p:spPr>
+        <p:txBody>
+          <a:bodyPr wrap="none">
+            <a:spAutoFit/>
+          </a:bodyPr>
+          <a:lstStyle/>
+          <a:p>
+            <a:pPr>
+              <a:defRPr sz="3200" b="1"/>
+            </a:pPr>
             <a:r>
               <a:t>🤖 This Week in Agentic AI</a:t>
             </a:r>
@@ -4442,67 +5422,166 @@
       </p:sp>
       <p:sp>
         <p:nvSpPr>
-          <p:cNvPr id="3" name="Content Placeholder 2"/>
-          <p:cNvSpPr>
-            <a:spLocks noGrp="1"/>
-          </p:cNvSpPr>
-          <p:nvPr>
-            <p:ph idx="1"/>
-          </p:nvPr>
-        </p:nvSpPr>
-        <p:spPr/>
-        <p:txBody>
-          <a:bodyPr/>
-          <a:lstStyle/>
-          <a:p>
-            <a:r>
-              <a:t>📊 This Week's Highlights</a:t>
-            </a:r>
-          </a:p>
-          <a:p>
-            <a:pPr/>
-          </a:p>
-          <a:p>
-            <a:pPr/>
-            <a:r>
-              <a:t>This week highlighted both the promise and peril of autonomous AI agents, with OpenAI</a:t>
-            </a:r>
-          </a:p>
-          <a:p>
-            <a:pPr/>
-            <a:r>
-              <a:t>introducing modular 'skills' while Claude's CLI incident exposed critical safety gaps in</a:t>
-            </a:r>
-          </a:p>
-          <a:p>
-            <a:pPr/>
-            <a:r>
-              <a:t>tool-using agents. Research advanced multi-agent learning and formal verification methods,</a:t>
-            </a:r>
-          </a:p>
-          <a:p>
-            <a:pPr/>
-            <a:r>
-              <a:t>while industry debates centered on the growing gap between impressive benchmarks and</a:t>
-            </a:r>
-          </a:p>
-          <a:p>
-            <a:pPr/>
-            <a:r>
-              <a:t>practical deployment challenges, particularly in enterprise SaaS replacement scenarios.</a:t>
-            </a:r>
-          </a:p>
-          <a:p>
-            <a:pPr/>
-          </a:p>
-          <a:p>
-            <a:pPr/>
+          <p:cNvPr id="3" name="TextBox 2"/>
+          <p:cNvSpPr txBox="1"/>
+          <p:nvPr/>
+        </p:nvSpPr>
+        <p:spPr>
+          <a:xfrm>
+            <a:off x="457200" y="1371600"/>
+            <a:ext cx="8229600" cy="685800"/>
+          </a:xfrm>
+          <a:prstGeom prst="rect">
+            <a:avLst/>
+          </a:prstGeom>
+          <a:noFill/>
+        </p:spPr>
+        <p:txBody>
+          <a:bodyPr wrap="none">
+            <a:spAutoFit/>
+          </a:bodyPr>
+          <a:lstStyle/>
+          <a:p>
+            <a:pPr>
+              <a:defRPr sz="1600" b="1">
+                <a:solidFill>
+                  <a:srgbClr val="FFFFFF"/>
+                </a:solidFill>
+              </a:defRPr>
+            </a:pPr>
+            <a:r>
+              <a:t>This Week's Highlights</a:t>
+            </a:r>
+          </a:p>
+        </p:txBody>
+      </p:sp>
+      <p:sp>
+        <p:nvSpPr>
+          <p:cNvPr id="4" name="TextBox 3"/>
+          <p:cNvSpPr txBox="1"/>
+          <p:nvPr/>
+        </p:nvSpPr>
+        <p:spPr>
+          <a:xfrm>
+            <a:off x="457200" y="2057400"/>
+            <a:ext cx="8229600" cy="685800"/>
+          </a:xfrm>
+          <a:prstGeom prst="rect">
+            <a:avLst/>
+          </a:prstGeom>
+          <a:noFill/>
+        </p:spPr>
+        <p:txBody>
+          <a:bodyPr wrap="none">
+            <a:spAutoFit/>
+          </a:bodyPr>
+          <a:lstStyle/>
+          <a:p>
+            <a:pPr>
+              <a:defRPr sz="1200">
+                <a:solidFill>
+                  <a:srgbClr val="FFFFFF"/>
+                </a:solidFill>
+              </a:defRPr>
+            </a:pPr>
+            <a:r>
+              <a:t>This week highlighted the rapid maturation of agentic AI with OpenAI quietly launching 'skills' for modular agent capabilities while safety concerns intensified following Claude CLI's file deletion incident. Multi-agent systems demonstrated breakthrough capabilities in competitive drone racing and cybersecurity penetration testing, signaling agents are moving from research demos to practical applications that can match human expert performance.</a:t>
+            </a:r>
+          </a:p>
+        </p:txBody>
+      </p:sp>
+      <p:sp>
+        <p:nvSpPr>
+          <p:cNvPr id="5" name="TextBox 4"/>
+          <p:cNvSpPr txBox="1"/>
+          <p:nvPr/>
+        </p:nvSpPr>
+        <p:spPr>
+          <a:xfrm>
+            <a:off x="457200" y="2743200"/>
+            <a:ext cx="8229600" cy="685800"/>
+          </a:xfrm>
+          <a:prstGeom prst="rect">
+            <a:avLst/>
+          </a:prstGeom>
+          <a:noFill/>
+        </p:spPr>
+        <p:txBody>
+          <a:bodyPr wrap="none">
+            <a:spAutoFit/>
+          </a:bodyPr>
+          <a:lstStyle/>
+          <a:p>
+            <a:pPr>
+              <a:defRPr sz="1000"/>
+            </a:pPr>
+          </a:p>
+        </p:txBody>
+      </p:sp>
+      <p:sp>
+        <p:nvSpPr>
+          <p:cNvPr id="6" name="TextBox 5"/>
+          <p:cNvSpPr txBox="1"/>
+          <p:nvPr/>
+        </p:nvSpPr>
+        <p:spPr>
+          <a:xfrm>
+            <a:off x="457200" y="3429000"/>
+            <a:ext cx="8229600" cy="685800"/>
+          </a:xfrm>
+          <a:prstGeom prst="rect">
+            <a:avLst/>
+          </a:prstGeom>
+          <a:noFill/>
+        </p:spPr>
+        <p:txBody>
+          <a:bodyPr wrap="none">
+            <a:spAutoFit/>
+          </a:bodyPr>
+          <a:lstStyle/>
+          <a:p>
+            <a:pPr>
+              <a:defRPr sz="1000" i="1">
+                <a:solidFill>
+                  <a:srgbClr val="CCCCCC"/>
+                </a:solidFill>
+              </a:defRPr>
+            </a:pPr>
             <a:r>
               <a:t>📚 arXiv • Hacker News • Reddit</a:t>
             </a:r>
           </a:p>
-          <a:p>
-            <a:pPr/>
+        </p:txBody>
+      </p:sp>
+      <p:sp>
+        <p:nvSpPr>
+          <p:cNvPr id="7" name="TextBox 6"/>
+          <p:cNvSpPr txBox="1"/>
+          <p:nvPr/>
+        </p:nvSpPr>
+        <p:spPr>
+          <a:xfrm>
+            <a:off x="457200" y="4114800"/>
+            <a:ext cx="8229600" cy="685800"/>
+          </a:xfrm>
+          <a:prstGeom prst="rect">
+            <a:avLst/>
+          </a:prstGeom>
+          <a:noFill/>
+        </p:spPr>
+        <p:txBody>
+          <a:bodyPr wrap="none">
+            <a:spAutoFit/>
+          </a:bodyPr>
+          <a:lstStyle/>
+          <a:p>
+            <a:pPr>
+              <a:defRPr sz="1000" i="1">
+                <a:solidFill>
+                  <a:srgbClr val="CCCCCC"/>
+                </a:solidFill>
+              </a:defRPr>
+            </a:pPr>
             <a:r>
               <a:t>🗓️  2025-12-15</a:t>
             </a:r>
@@ -4511,7 +5590,7 @@
       </p:sp>
       <p:sp>
         <p:nvSpPr>
-          <p:cNvPr id="4" name="TextBox 3"/>
+          <p:cNvPr id="8" name="TextBox 7"/>
           <p:cNvSpPr txBox="1"/>
           <p:nvPr/>
         </p:nvSpPr>
@@ -4549,594 +5628,6 @@
 </file>
 
 <file path=ppt/slides/slide20.xml><?xml version="1.0" encoding="utf-8"?>
-<p:sld xmlns:a="http://schemas.openxmlformats.org/drawingml/2006/main" xmlns:p="http://schemas.openxmlformats.org/presentationml/2006/main" xmlns:r="http://schemas.openxmlformats.org/officeDocument/2006/relationships">
-  <p:cSld>
-    <p:bg>
-      <p:bgPr>
-        <a:solidFill>
-          <a:srgbClr val="E67E22"/>
-        </a:solidFill>
-        <a:effectLst/>
-      </p:bgPr>
-    </p:bg>
-    <p:spTree>
-      <p:nvGrpSpPr>
-        <p:cNvPr id="1" name=""/>
-        <p:cNvGrpSpPr/>
-        <p:nvPr/>
-      </p:nvGrpSpPr>
-      <p:grpSpPr/>
-      <p:sp>
-        <p:nvSpPr>
-          <p:cNvPr id="2" name="Title 1"/>
-          <p:cNvSpPr>
-            <a:spLocks noGrp="1"/>
-          </p:cNvSpPr>
-          <p:nvPr>
-            <p:ph type="title"/>
-          </p:nvPr>
-        </p:nvSpPr>
-        <p:spPr/>
-        <p:txBody>
-          <a:bodyPr/>
-          <a:lstStyle/>
-          <a:p>
-            <a:r>
-              <a:t>💬 Notable Discussions</a:t>
-            </a:r>
-          </a:p>
-        </p:txBody>
-      </p:sp>
-      <p:sp>
-        <p:nvSpPr>
-          <p:cNvPr id="3" name="Content Placeholder 2"/>
-          <p:cNvSpPr>
-            <a:spLocks noGrp="1"/>
-          </p:cNvSpPr>
-          <p:nvPr>
-            <p:ph idx="1"/>
-          </p:nvPr>
-        </p:nvSpPr>
-        <p:spPr/>
-        <p:txBody>
-          <a:bodyPr/>
-          <a:lstStyle/>
-          <a:p>
-            <a:r>
-              <a:t>4 key updates this week</a:t>
-            </a:r>
-          </a:p>
-          <a:p>
-            <a:pPr/>
-          </a:p>
-          <a:p>
-            <a:pPr/>
-            <a:r>
-              <a:t>→ Swipe to explore</a:t>
-            </a:r>
-          </a:p>
-        </p:txBody>
-      </p:sp>
-      <p:sp>
-        <p:nvSpPr>
-          <p:cNvPr id="4" name="TextBox 3"/>
-          <p:cNvSpPr txBox="1"/>
-          <p:nvPr/>
-        </p:nvSpPr>
-        <p:spPr>
-          <a:xfrm>
-            <a:off x="457200" y="6400800"/>
-            <a:ext cx="7315200" cy="274320"/>
-          </a:xfrm>
-          <a:prstGeom prst="rect">
-            <a:avLst/>
-          </a:prstGeom>
-          <a:noFill/>
-        </p:spPr>
-        <p:txBody>
-          <a:bodyPr wrap="none">
-            <a:spAutoFit/>
-          </a:bodyPr>
-          <a:lstStyle/>
-          <a:p>
-            <a:pPr algn="ctr">
-              <a:defRPr sz="1000"/>
-            </a:pPr>
-            <a:r>
-              <a:t>Slide 20</a:t>
-            </a:r>
-          </a:p>
-        </p:txBody>
-      </p:sp>
-    </p:spTree>
-  </p:cSld>
-  <p:clrMapOvr>
-    <a:masterClrMapping/>
-  </p:clrMapOvr>
-</p:sld>
-</file>
-
-<file path=ppt/slides/slide21.xml><?xml version="1.0" encoding="utf-8"?>
-<p:sld xmlns:a="http://schemas.openxmlformats.org/drawingml/2006/main" xmlns:p="http://schemas.openxmlformats.org/presentationml/2006/main" xmlns:r="http://schemas.openxmlformats.org/officeDocument/2006/relationships">
-  <p:cSld>
-    <p:bg>
-      <p:bgPr>
-        <a:solidFill>
-          <a:srgbClr val="F5F7FA"/>
-        </a:solidFill>
-        <a:effectLst/>
-      </p:bgPr>
-    </p:bg>
-    <p:spTree>
-      <p:nvGrpSpPr>
-        <p:cNvPr id="1" name=""/>
-        <p:cNvGrpSpPr/>
-        <p:nvPr/>
-      </p:nvGrpSpPr>
-      <p:grpSpPr/>
-      <p:sp>
-        <p:nvSpPr>
-          <p:cNvPr id="2" name="Title 1"/>
-          <p:cNvSpPr>
-            <a:spLocks noGrp="1"/>
-          </p:cNvSpPr>
-          <p:nvPr>
-            <p:ph type="title"/>
-          </p:nvPr>
-        </p:nvSpPr>
-        <p:spPr/>
-        <p:txBody>
-          <a:bodyPr/>
-          <a:lstStyle/>
-          <a:p>
-            <a:r>
-              <a:t>1. Ilya Sutskever is puzzled by the gap between AI benchmarks and the econo...</a:t>
-            </a:r>
-          </a:p>
-        </p:txBody>
-      </p:sp>
-      <p:sp>
-        <p:nvSpPr>
-          <p:cNvPr id="3" name="Content Placeholder 2"/>
-          <p:cNvSpPr>
-            <a:spLocks noGrp="1"/>
-          </p:cNvSpPr>
-          <p:nvPr>
-            <p:ph idx="1"/>
-          </p:nvPr>
-        </p:nvSpPr>
-        <p:spPr/>
-        <p:txBody>
-          <a:bodyPr/>
-          <a:lstStyle/>
-          <a:p>
-            <a:r>
-              <a:t>Key AI researcher questions why impressive agent benchmarks haven't translated to</a:t>
-            </a:r>
-          </a:p>
-          <a:p>
-            <a:pPr/>
-            <a:r>
-              <a:t>proportional real-world impact, highlighting deployment and integration challenges.</a:t>
-            </a:r>
-          </a:p>
-          <a:p>
-            <a:pPr/>
-          </a:p>
-          <a:p>
-            <a:pPr/>
-            <a:r>
-              <a:t>📍 r/MachineLearning • 384 upvotes • 191 comments</a:t>
-            </a:r>
-          </a:p>
-          <a:p>
-            <a:pPr/>
-            <a:r>
-              <a:t>🔗 https://reddit.com/r/MachineLearning/comments/1pm2zsb/ilya_sutskever_is_...</a:t>
-            </a:r>
-          </a:p>
-        </p:txBody>
-      </p:sp>
-      <p:sp>
-        <p:nvSpPr>
-          <p:cNvPr id="4" name="TextBox 3"/>
-          <p:cNvSpPr txBox="1"/>
-          <p:nvPr/>
-        </p:nvSpPr>
-        <p:spPr>
-          <a:xfrm>
-            <a:off x="457200" y="6400800"/>
-            <a:ext cx="7315200" cy="274320"/>
-          </a:xfrm>
-          <a:prstGeom prst="rect">
-            <a:avLst/>
-          </a:prstGeom>
-          <a:noFill/>
-        </p:spPr>
-        <p:txBody>
-          <a:bodyPr wrap="none">
-            <a:spAutoFit/>
-          </a:bodyPr>
-          <a:lstStyle/>
-          <a:p>
-            <a:pPr algn="ctr">
-              <a:defRPr sz="1000"/>
-            </a:pPr>
-            <a:r>
-              <a:t>Slide 21</a:t>
-            </a:r>
-          </a:p>
-        </p:txBody>
-      </p:sp>
-    </p:spTree>
-  </p:cSld>
-  <p:clrMapOvr>
-    <a:masterClrMapping/>
-  </p:clrMapOvr>
-</p:sld>
-</file>
-
-<file path=ppt/slides/slide22.xml><?xml version="1.0" encoding="utf-8"?>
-<p:sld xmlns:a="http://schemas.openxmlformats.org/drawingml/2006/main" xmlns:p="http://schemas.openxmlformats.org/presentationml/2006/main" xmlns:r="http://schemas.openxmlformats.org/officeDocument/2006/relationships">
-  <p:cSld>
-    <p:bg>
-      <p:bgPr>
-        <a:solidFill>
-          <a:srgbClr val="F5F7FA"/>
-        </a:solidFill>
-        <a:effectLst/>
-      </p:bgPr>
-    </p:bg>
-    <p:spTree>
-      <p:nvGrpSpPr>
-        <p:cNvPr id="1" name=""/>
-        <p:cNvGrpSpPr/>
-        <p:nvPr/>
-      </p:nvGrpSpPr>
-      <p:grpSpPr/>
-      <p:sp>
-        <p:nvSpPr>
-          <p:cNvPr id="2" name="Title 1"/>
-          <p:cNvSpPr>
-            <a:spLocks noGrp="1"/>
-          </p:cNvSpPr>
-          <p:nvPr>
-            <p:ph type="title"/>
-          </p:nvPr>
-        </p:nvSpPr>
-        <p:spPr/>
-        <p:txBody>
-          <a:bodyPr/>
-          <a:lstStyle/>
-          <a:p>
-            <a:r>
-              <a:t>2. AI agents are starting to eat SaaS - Discussion</a:t>
-            </a:r>
-          </a:p>
-        </p:txBody>
-      </p:sp>
-      <p:sp>
-        <p:nvSpPr>
-          <p:cNvPr id="3" name="Content Placeholder 2"/>
-          <p:cNvSpPr>
-            <a:spLocks noGrp="1"/>
-          </p:cNvSpPr>
-          <p:nvPr>
-            <p:ph idx="1"/>
-          </p:nvPr>
-        </p:nvSpPr>
-        <p:spPr/>
-        <p:txBody>
-          <a:bodyPr/>
-          <a:lstStyle/>
-          <a:p>
-            <a:r>
-              <a:t>Community debate on whether autonomous agents will replace traditional SaaS tools,</a:t>
-            </a:r>
-          </a:p>
-          <a:p>
-            <a:pPr/>
-            <a:r>
-              <a:t>exploring implications for software architecture and business models.</a:t>
-            </a:r>
-          </a:p>
-          <a:p>
-            <a:pPr/>
-          </a:p>
-          <a:p>
-            <a:pPr/>
-            <a:r>
-              <a:t>📍 Hacker News • 119 points • 138 comments</a:t>
-            </a:r>
-          </a:p>
-          <a:p>
-            <a:pPr/>
-            <a:r>
-              <a:t>🔗 https://martinalderson.com/posts/ai-agents-are-starting-to-eat-saas/</a:t>
-            </a:r>
-          </a:p>
-        </p:txBody>
-      </p:sp>
-      <p:sp>
-        <p:nvSpPr>
-          <p:cNvPr id="4" name="TextBox 3"/>
-          <p:cNvSpPr txBox="1"/>
-          <p:nvPr/>
-        </p:nvSpPr>
-        <p:spPr>
-          <a:xfrm>
-            <a:off x="457200" y="6400800"/>
-            <a:ext cx="7315200" cy="274320"/>
-          </a:xfrm>
-          <a:prstGeom prst="rect">
-            <a:avLst/>
-          </a:prstGeom>
-          <a:noFill/>
-        </p:spPr>
-        <p:txBody>
-          <a:bodyPr wrap="none">
-            <a:spAutoFit/>
-          </a:bodyPr>
-          <a:lstStyle/>
-          <a:p>
-            <a:pPr algn="ctr">
-              <a:defRPr sz="1000"/>
-            </a:pPr>
-            <a:r>
-              <a:t>Slide 22</a:t>
-            </a:r>
-          </a:p>
-        </p:txBody>
-      </p:sp>
-    </p:spTree>
-  </p:cSld>
-  <p:clrMapOvr>
-    <a:masterClrMapping/>
-  </p:clrMapOvr>
-</p:sld>
-</file>
-
-<file path=ppt/slides/slide23.xml><?xml version="1.0" encoding="utf-8"?>
-<p:sld xmlns:a="http://schemas.openxmlformats.org/drawingml/2006/main" xmlns:p="http://schemas.openxmlformats.org/presentationml/2006/main" xmlns:r="http://schemas.openxmlformats.org/officeDocument/2006/relationships">
-  <p:cSld>
-    <p:bg>
-      <p:bgPr>
-        <a:solidFill>
-          <a:srgbClr val="F5F7FA"/>
-        </a:solidFill>
-        <a:effectLst/>
-      </p:bgPr>
-    </p:bg>
-    <p:spTree>
-      <p:nvGrpSpPr>
-        <p:cNvPr id="1" name=""/>
-        <p:cNvGrpSpPr/>
-        <p:nvPr/>
-      </p:nvGrpSpPr>
-      <p:grpSpPr/>
-      <p:sp>
-        <p:nvSpPr>
-          <p:cNvPr id="2" name="Title 1"/>
-          <p:cNvSpPr>
-            <a:spLocks noGrp="1"/>
-          </p:cNvSpPr>
-          <p:nvPr>
-            <p:ph type="title"/>
-          </p:nvPr>
-        </p:nvSpPr>
-        <p:spPr/>
-        <p:txBody>
-          <a:bodyPr/>
-          <a:lstStyle/>
-          <a:p>
-            <a:r>
-              <a:t>3. Claude CLI Safety Incident Discussion</a:t>
-            </a:r>
-          </a:p>
-        </p:txBody>
-      </p:sp>
-      <p:sp>
-        <p:nvSpPr>
-          <p:cNvPr id="3" name="Content Placeholder 2"/>
-          <p:cNvSpPr>
-            <a:spLocks noGrp="1"/>
-          </p:cNvSpPr>
-          <p:nvPr>
-            <p:ph idx="1"/>
-          </p:nvPr>
-        </p:nvSpPr>
-        <p:spPr/>
-        <p:txBody>
-          <a:bodyPr/>
-          <a:lstStyle/>
-          <a:p>
-            <a:r>
-              <a:t>Critical community discussion on safety mechanisms for tool-using agents, revealing urgent</a:t>
-            </a:r>
-          </a:p>
-          <a:p>
-            <a:pPr/>
-            <a:r>
-              <a:t>need for better sandboxing and permission systems in agent frameworks.</a:t>
-            </a:r>
-          </a:p>
-          <a:p>
-            <a:pPr/>
-          </a:p>
-          <a:p>
-            <a:pPr/>
-            <a:r>
-              <a:t>📍 Hacker News • 220 points • 179 comments</a:t>
-            </a:r>
-          </a:p>
-          <a:p>
-            <a:pPr/>
-            <a:r>
-              <a:t>🔗 https://old.reddit.com/r/ClaudeAI/comments/1pgxckk/claude_cli_deleted_my...</a:t>
-            </a:r>
-          </a:p>
-        </p:txBody>
-      </p:sp>
-      <p:sp>
-        <p:nvSpPr>
-          <p:cNvPr id="4" name="TextBox 3"/>
-          <p:cNvSpPr txBox="1"/>
-          <p:nvPr/>
-        </p:nvSpPr>
-        <p:spPr>
-          <a:xfrm>
-            <a:off x="457200" y="6400800"/>
-            <a:ext cx="7315200" cy="274320"/>
-          </a:xfrm>
-          <a:prstGeom prst="rect">
-            <a:avLst/>
-          </a:prstGeom>
-          <a:noFill/>
-        </p:spPr>
-        <p:txBody>
-          <a:bodyPr wrap="none">
-            <a:spAutoFit/>
-          </a:bodyPr>
-          <a:lstStyle/>
-          <a:p>
-            <a:pPr algn="ctr">
-              <a:defRPr sz="1000"/>
-            </a:pPr>
-            <a:r>
-              <a:t>Slide 23</a:t>
-            </a:r>
-          </a:p>
-        </p:txBody>
-      </p:sp>
-    </p:spTree>
-  </p:cSld>
-  <p:clrMapOvr>
-    <a:masterClrMapping/>
-  </p:clrMapOvr>
-</p:sld>
-</file>
-
-<file path=ppt/slides/slide24.xml><?xml version="1.0" encoding="utf-8"?>
-<p:sld xmlns:a="http://schemas.openxmlformats.org/drawingml/2006/main" xmlns:p="http://schemas.openxmlformats.org/presentationml/2006/main" xmlns:r="http://schemas.openxmlformats.org/officeDocument/2006/relationships">
-  <p:cSld>
-    <p:bg>
-      <p:bgPr>
-        <a:solidFill>
-          <a:srgbClr val="F5F7FA"/>
-        </a:solidFill>
-        <a:effectLst/>
-      </p:bgPr>
-    </p:bg>
-    <p:spTree>
-      <p:nvGrpSpPr>
-        <p:cNvPr id="1" name=""/>
-        <p:cNvGrpSpPr/>
-        <p:nvPr/>
-      </p:nvGrpSpPr>
-      <p:grpSpPr/>
-      <p:sp>
-        <p:nvSpPr>
-          <p:cNvPr id="2" name="Title 1"/>
-          <p:cNvSpPr>
-            <a:spLocks noGrp="1"/>
-          </p:cNvSpPr>
-          <p:nvPr>
-            <p:ph type="title"/>
-          </p:nvPr>
-        </p:nvSpPr>
-        <p:spPr/>
-        <p:txBody>
-          <a:bodyPr/>
-          <a:lstStyle/>
-          <a:p>
-            <a:r>
-              <a:t>4. Stanford AI Agent Penetration Testing Success</a:t>
-            </a:r>
-          </a:p>
-        </p:txBody>
-      </p:sp>
-      <p:sp>
-        <p:nvSpPr>
-          <p:cNvPr id="3" name="Content Placeholder 2"/>
-          <p:cNvSpPr>
-            <a:spLocks noGrp="1"/>
-          </p:cNvSpPr>
-          <p:nvPr>
-            <p:ph idx="1"/>
-          </p:nvPr>
-        </p:nvSpPr>
-        <p:spPr/>
-        <p:txBody>
-          <a:bodyPr/>
-          <a:lstStyle/>
-          <a:p>
-            <a:r>
-              <a:t>Discussion explores implications of autonomous agents matching expert performance in</a:t>
-            </a:r>
-          </a:p>
-          <a:p>
-            <a:pPr/>
-            <a:r>
-              <a:t>complex planning tasks, raising questions about agent reliability and economic disruption.</a:t>
-            </a:r>
-          </a:p>
-          <a:p>
-            <a:pPr/>
-          </a:p>
-          <a:p>
-            <a:pPr/>
-            <a:r>
-              <a:t>📍 r/artificial • 206 upvotes • 32 comments</a:t>
-            </a:r>
-          </a:p>
-          <a:p>
-            <a:pPr/>
-            <a:r>
-              <a:t>🔗 https://reddit.com/r/artificial/comments/1pkuaaq/an_ai_agent_spent_16_ho...</a:t>
-            </a:r>
-          </a:p>
-        </p:txBody>
-      </p:sp>
-      <p:sp>
-        <p:nvSpPr>
-          <p:cNvPr id="4" name="TextBox 3"/>
-          <p:cNvSpPr txBox="1"/>
-          <p:nvPr/>
-        </p:nvSpPr>
-        <p:spPr>
-          <a:xfrm>
-            <a:off x="457200" y="6400800"/>
-            <a:ext cx="7315200" cy="274320"/>
-          </a:xfrm>
-          <a:prstGeom prst="rect">
-            <a:avLst/>
-          </a:prstGeom>
-          <a:noFill/>
-        </p:spPr>
-        <p:txBody>
-          <a:bodyPr wrap="none">
-            <a:spAutoFit/>
-          </a:bodyPr>
-          <a:lstStyle/>
-          <a:p>
-            <a:pPr algn="ctr">
-              <a:defRPr sz="1000"/>
-            </a:pPr>
-            <a:r>
-              <a:t>Slide 24</a:t>
-            </a:r>
-          </a:p>
-        </p:txBody>
-      </p:sp>
-    </p:spTree>
-  </p:cSld>
-  <p:clrMapOvr>
-    <a:masterClrMapping/>
-  </p:clrMapOvr>
-</p:sld>
-</file>
-
-<file path=ppt/slides/slide25.xml><?xml version="1.0" encoding="utf-8"?>
 <p:sld xmlns:a="http://schemas.openxmlformats.org/drawingml/2006/main" xmlns:p="http://schemas.openxmlformats.org/presentationml/2006/main" xmlns:r="http://schemas.openxmlformats.org/officeDocument/2006/relationships">
   <p:cSld>
     <p:bg>
@@ -5156,19 +5647,29 @@
       <p:grpSpPr/>
       <p:sp>
         <p:nvSpPr>
-          <p:cNvPr id="2" name="Title 1"/>
-          <p:cNvSpPr>
-            <a:spLocks noGrp="1"/>
-          </p:cNvSpPr>
-          <p:nvPr>
-            <p:ph type="title"/>
-          </p:nvPr>
-        </p:nvSpPr>
-        <p:spPr/>
-        <p:txBody>
-          <a:bodyPr/>
-          <a:lstStyle/>
-          <a:p>
+          <p:cNvPr id="2" name="TextBox 1"/>
+          <p:cNvSpPr txBox="1"/>
+          <p:nvPr/>
+        </p:nvSpPr>
+        <p:spPr>
+          <a:xfrm>
+            <a:off x="457200" y="457200"/>
+            <a:ext cx="8229600" cy="685800"/>
+          </a:xfrm>
+          <a:prstGeom prst="rect">
+            <a:avLst/>
+          </a:prstGeom>
+          <a:noFill/>
+        </p:spPr>
+        <p:txBody>
+          <a:bodyPr wrap="none">
+            <a:spAutoFit/>
+          </a:bodyPr>
+          <a:lstStyle/>
+          <a:p>
+            <a:pPr>
+              <a:defRPr sz="3200" b="1"/>
+            </a:pPr>
             <a:r>
               <a:t>✨ Stay Curious</a:t>
             </a:r>
@@ -5177,61 +5678,229 @@
       </p:sp>
       <p:sp>
         <p:nvSpPr>
-          <p:cNvPr id="3" name="Content Placeholder 2"/>
-          <p:cNvSpPr>
-            <a:spLocks noGrp="1"/>
-          </p:cNvSpPr>
-          <p:nvPr>
-            <p:ph idx="1"/>
-          </p:nvPr>
-        </p:nvSpPr>
-        <p:spPr/>
-        <p:txBody>
-          <a:bodyPr/>
-          <a:lstStyle/>
-          <a:p>
+          <p:cNvPr id="3" name="TextBox 2"/>
+          <p:cNvSpPr txBox="1"/>
+          <p:nvPr/>
+        </p:nvSpPr>
+        <p:spPr>
+          <a:xfrm>
+            <a:off x="457200" y="1371600"/>
+            <a:ext cx="8229600" cy="685800"/>
+          </a:xfrm>
+          <a:prstGeom prst="rect">
+            <a:avLst/>
+          </a:prstGeom>
+          <a:noFill/>
+        </p:spPr>
+        <p:txBody>
+          <a:bodyPr wrap="none">
+            <a:spAutoFit/>
+          </a:bodyPr>
+          <a:lstStyle/>
+          <a:p>
+            <a:pPr>
+              <a:defRPr sz="1600" b="1">
+                <a:solidFill>
+                  <a:srgbClr val="FFFFFF"/>
+                </a:solidFill>
+              </a:defRPr>
+            </a:pPr>
             <a:r>
               <a:t>Your weekly AI digest</a:t>
             </a:r>
           </a:p>
-          <a:p>
-            <a:pPr/>
+        </p:txBody>
+      </p:sp>
+      <p:sp>
+        <p:nvSpPr>
+          <p:cNvPr id="4" name="TextBox 3"/>
+          <p:cNvSpPr txBox="1"/>
+          <p:nvPr/>
+        </p:nvSpPr>
+        <p:spPr>
+          <a:xfrm>
+            <a:off x="457200" y="2057400"/>
+            <a:ext cx="8229600" cy="685800"/>
+          </a:xfrm>
+          <a:prstGeom prst="rect">
+            <a:avLst/>
+          </a:prstGeom>
+          <a:noFill/>
+        </p:spPr>
+        <p:txBody>
+          <a:bodyPr wrap="none">
+            <a:spAutoFit/>
+          </a:bodyPr>
+          <a:lstStyle/>
+          <a:p>
+            <a:pPr>
+              <a:defRPr sz="1200" i="1">
+                <a:solidFill>
+                  <a:srgbClr val="EEEEEE"/>
+                </a:solidFill>
+              </a:defRPr>
+            </a:pPr>
             <a:r>
               <a:t>Automatically curated every Sunday at 6 PM</a:t>
             </a:r>
           </a:p>
-          <a:p>
-            <a:pPr/>
-          </a:p>
-          <a:p>
-            <a:pPr/>
+        </p:txBody>
+      </p:sp>
+      <p:sp>
+        <p:nvSpPr>
+          <p:cNvPr id="5" name="TextBox 4"/>
+          <p:cNvSpPr txBox="1"/>
+          <p:nvPr/>
+        </p:nvSpPr>
+        <p:spPr>
+          <a:xfrm>
+            <a:off x="457200" y="2743200"/>
+            <a:ext cx="8229600" cy="685800"/>
+          </a:xfrm>
+          <a:prstGeom prst="rect">
+            <a:avLst/>
+          </a:prstGeom>
+          <a:noFill/>
+        </p:spPr>
+        <p:txBody>
+          <a:bodyPr wrap="none">
+            <a:spAutoFit/>
+          </a:bodyPr>
+          <a:lstStyle/>
+          <a:p>
+            <a:pPr>
+              <a:defRPr sz="1000"/>
+            </a:pPr>
+          </a:p>
+        </p:txBody>
+      </p:sp>
+      <p:sp>
+        <p:nvSpPr>
+          <p:cNvPr id="6" name="TextBox 5"/>
+          <p:cNvSpPr txBox="1"/>
+          <p:nvPr/>
+        </p:nvSpPr>
+        <p:spPr>
+          <a:xfrm>
+            <a:off x="457200" y="3429000"/>
+            <a:ext cx="8229600" cy="685800"/>
+          </a:xfrm>
+          <a:prstGeom prst="rect">
+            <a:avLst/>
+          </a:prstGeom>
+          <a:noFill/>
+        </p:spPr>
+        <p:txBody>
+          <a:bodyPr wrap="none">
+            <a:spAutoFit/>
+          </a:bodyPr>
+          <a:lstStyle/>
+          <a:p>
+            <a:pPr>
+              <a:defRPr sz="1200" b="1">
+                <a:solidFill>
+                  <a:srgbClr val="FFFFFF"/>
+                </a:solidFill>
+              </a:defRPr>
+            </a:pPr>
             <a:r>
               <a:t>🔬 Data Sources:</a:t>
             </a:r>
           </a:p>
-          <a:p>
-            <a:pPr/>
-            <a:r>
-              <a:t>  • arXiv Research Papers</a:t>
-            </a:r>
-          </a:p>
-          <a:p>
-            <a:pPr/>
-            <a:r>
-              <a:t>  • Hacker News</a:t>
-            </a:r>
-          </a:p>
-          <a:p>
-            <a:pPr/>
-            <a:r>
-              <a:t>  • Reddit ML Communities</a:t>
-            </a:r>
-          </a:p>
-          <a:p>
-            <a:pPr/>
-          </a:p>
-          <a:p>
-            <a:pPr/>
+        </p:txBody>
+      </p:sp>
+      <p:sp>
+        <p:nvSpPr>
+          <p:cNvPr id="7" name="TextBox 6"/>
+          <p:cNvSpPr txBox="1"/>
+          <p:nvPr/>
+        </p:nvSpPr>
+        <p:spPr>
+          <a:xfrm>
+            <a:off x="457200" y="4114800"/>
+            <a:ext cx="8229600" cy="685800"/>
+          </a:xfrm>
+          <a:prstGeom prst="rect">
+            <a:avLst/>
+          </a:prstGeom>
+          <a:noFill/>
+        </p:spPr>
+        <p:txBody>
+          <a:bodyPr wrap="none">
+            <a:spAutoFit/>
+          </a:bodyPr>
+          <a:lstStyle/>
+          <a:p>
+            <a:pPr>
+              <a:defRPr sz="1100">
+                <a:solidFill>
+                  <a:srgbClr val="EEEEEE"/>
+                </a:solidFill>
+              </a:defRPr>
+            </a:pPr>
+            <a:r>
+              <a:t>arXiv Research Papers • Hacker News • Reddit ML Communities</a:t>
+            </a:r>
+          </a:p>
+        </p:txBody>
+      </p:sp>
+      <p:sp>
+        <p:nvSpPr>
+          <p:cNvPr id="8" name="TextBox 7"/>
+          <p:cNvSpPr txBox="1"/>
+          <p:nvPr/>
+        </p:nvSpPr>
+        <p:spPr>
+          <a:xfrm>
+            <a:off x="457200" y="4800600"/>
+            <a:ext cx="8229600" cy="685800"/>
+          </a:xfrm>
+          <a:prstGeom prst="rect">
+            <a:avLst/>
+          </a:prstGeom>
+          <a:noFill/>
+        </p:spPr>
+        <p:txBody>
+          <a:bodyPr wrap="none">
+            <a:spAutoFit/>
+          </a:bodyPr>
+          <a:lstStyle/>
+          <a:p>
+            <a:pPr>
+              <a:defRPr sz="1000"/>
+            </a:pPr>
+          </a:p>
+        </p:txBody>
+      </p:sp>
+      <p:sp>
+        <p:nvSpPr>
+          <p:cNvPr id="9" name="TextBox 8"/>
+          <p:cNvSpPr txBox="1"/>
+          <p:nvPr/>
+        </p:nvSpPr>
+        <p:spPr>
+          <a:xfrm>
+            <a:off x="457200" y="5486400"/>
+            <a:ext cx="8229600" cy="685800"/>
+          </a:xfrm>
+          <a:prstGeom prst="rect">
+            <a:avLst/>
+          </a:prstGeom>
+          <a:noFill/>
+        </p:spPr>
+        <p:txBody>
+          <a:bodyPr wrap="none">
+            <a:spAutoFit/>
+          </a:bodyPr>
+          <a:lstStyle/>
+          <a:p>
+            <a:pPr>
+              <a:defRPr sz="1100" i="1">
+                <a:solidFill>
+                  <a:srgbClr val="CCCCCC"/>
+                </a:solidFill>
+              </a:defRPr>
+            </a:pPr>
             <a:r>
               <a:t>📅 Next edition: December 21, 2025</a:t>
             </a:r>
@@ -5240,7 +5909,7 @@
       </p:sp>
       <p:sp>
         <p:nvSpPr>
-          <p:cNvPr id="4" name="TextBox 3"/>
+          <p:cNvPr id="10" name="TextBox 9"/>
           <p:cNvSpPr txBox="1"/>
           <p:nvPr/>
         </p:nvSpPr>
@@ -5264,7 +5933,7 @@
               <a:defRPr sz="1000"/>
             </a:pPr>
             <a:r>
-              <a:t>Slide 25</a:t>
+              <a:t>Slide 20</a:t>
             </a:r>
           </a:p>
         </p:txBody>
@@ -5297,19 +5966,29 @@
       <p:grpSpPr/>
       <p:sp>
         <p:nvSpPr>
-          <p:cNvPr id="2" name="Title 1"/>
-          <p:cNvSpPr>
-            <a:spLocks noGrp="1"/>
-          </p:cNvSpPr>
-          <p:nvPr>
-            <p:ph type="title"/>
-          </p:nvPr>
-        </p:nvSpPr>
-        <p:spPr/>
-        <p:txBody>
-          <a:bodyPr/>
-          <a:lstStyle/>
-          <a:p>
+          <p:cNvPr id="2" name="TextBox 1"/>
+          <p:cNvSpPr txBox="1"/>
+          <p:nvPr/>
+        </p:nvSpPr>
+        <p:spPr>
+          <a:xfrm>
+            <a:off x="457200" y="457200"/>
+            <a:ext cx="8229600" cy="685800"/>
+          </a:xfrm>
+          <a:prstGeom prst="rect">
+            <a:avLst/>
+          </a:prstGeom>
+          <a:noFill/>
+        </p:spPr>
+        <p:txBody>
+          <a:bodyPr wrap="none">
+            <a:spAutoFit/>
+          </a:bodyPr>
+          <a:lstStyle/>
+          <a:p>
+            <a:pPr>
+              <a:defRPr sz="3200" b="1"/>
+            </a:pPr>
             <a:r>
               <a:t>🔬 Key Research Papers</a:t>
             </a:r>
@@ -5318,28 +5997,96 @@
       </p:sp>
       <p:sp>
         <p:nvSpPr>
-          <p:cNvPr id="3" name="Content Placeholder 2"/>
-          <p:cNvSpPr>
-            <a:spLocks noGrp="1"/>
-          </p:cNvSpPr>
-          <p:nvPr>
-            <p:ph idx="1"/>
-          </p:nvPr>
-        </p:nvSpPr>
-        <p:spPr/>
-        <p:txBody>
-          <a:bodyPr/>
-          <a:lstStyle/>
-          <a:p>
+          <p:cNvPr id="3" name="TextBox 2"/>
+          <p:cNvSpPr txBox="1"/>
+          <p:nvPr/>
+        </p:nvSpPr>
+        <p:spPr>
+          <a:xfrm>
+            <a:off x="457200" y="1371600"/>
+            <a:ext cx="8229600" cy="685800"/>
+          </a:xfrm>
+          <a:prstGeom prst="rect">
+            <a:avLst/>
+          </a:prstGeom>
+          <a:noFill/>
+        </p:spPr>
+        <p:txBody>
+          <a:bodyPr wrap="none">
+            <a:spAutoFit/>
+          </a:bodyPr>
+          <a:lstStyle/>
+          <a:p>
+            <a:pPr>
+              <a:defRPr sz="1800" b="1">
+                <a:solidFill>
+                  <a:srgbClr val="FFFFFF"/>
+                </a:solidFill>
+              </a:defRPr>
+            </a:pPr>
             <a:r>
               <a:t>5 key updates this week</a:t>
             </a:r>
           </a:p>
-          <a:p>
-            <a:pPr/>
-          </a:p>
-          <a:p>
-            <a:pPr/>
+        </p:txBody>
+      </p:sp>
+      <p:sp>
+        <p:nvSpPr>
+          <p:cNvPr id="4" name="TextBox 3"/>
+          <p:cNvSpPr txBox="1"/>
+          <p:nvPr/>
+        </p:nvSpPr>
+        <p:spPr>
+          <a:xfrm>
+            <a:off x="457200" y="2057400"/>
+            <a:ext cx="8229600" cy="685800"/>
+          </a:xfrm>
+          <a:prstGeom prst="rect">
+            <a:avLst/>
+          </a:prstGeom>
+          <a:noFill/>
+        </p:spPr>
+        <p:txBody>
+          <a:bodyPr wrap="none">
+            <a:spAutoFit/>
+          </a:bodyPr>
+          <a:lstStyle/>
+          <a:p>
+            <a:pPr>
+              <a:defRPr sz="1200"/>
+            </a:pPr>
+          </a:p>
+        </p:txBody>
+      </p:sp>
+      <p:sp>
+        <p:nvSpPr>
+          <p:cNvPr id="5" name="TextBox 4"/>
+          <p:cNvSpPr txBox="1"/>
+          <p:nvPr/>
+        </p:nvSpPr>
+        <p:spPr>
+          <a:xfrm>
+            <a:off x="457200" y="2743200"/>
+            <a:ext cx="8229600" cy="685800"/>
+          </a:xfrm>
+          <a:prstGeom prst="rect">
+            <a:avLst/>
+          </a:prstGeom>
+          <a:noFill/>
+        </p:spPr>
+        <p:txBody>
+          <a:bodyPr wrap="none">
+            <a:spAutoFit/>
+          </a:bodyPr>
+          <a:lstStyle/>
+          <a:p>
+            <a:pPr>
+              <a:defRPr sz="1400" i="1">
+                <a:solidFill>
+                  <a:srgbClr val="FFFFFF"/>
+                </a:solidFill>
+              </a:defRPr>
+            </a:pPr>
             <a:r>
               <a:t>→ Swipe to explore</a:t>
             </a:r>
@@ -5348,7 +6095,7 @@
       </p:sp>
       <p:sp>
         <p:nvSpPr>
-          <p:cNvPr id="4" name="TextBox 3"/>
+          <p:cNvPr id="6" name="TextBox 5"/>
           <p:cNvSpPr txBox="1"/>
           <p:nvPr/>
         </p:nvSpPr>
@@ -5405,19 +6152,29 @@
       <p:grpSpPr/>
       <p:sp>
         <p:nvSpPr>
-          <p:cNvPr id="2" name="Title 1"/>
-          <p:cNvSpPr>
-            <a:spLocks noGrp="1"/>
-          </p:cNvSpPr>
-          <p:nvPr>
-            <p:ph type="title"/>
-          </p:nvPr>
-        </p:nvSpPr>
-        <p:spPr/>
-        <p:txBody>
-          <a:bodyPr/>
-          <a:lstStyle/>
-          <a:p>
+          <p:cNvPr id="2" name="TextBox 1"/>
+          <p:cNvSpPr txBox="1"/>
+          <p:nvPr/>
+        </p:nvSpPr>
+        <p:spPr>
+          <a:xfrm>
+            <a:off x="457200" y="457200"/>
+            <a:ext cx="8229600" cy="685800"/>
+          </a:xfrm>
+          <a:prstGeom prst="rect">
+            <a:avLst/>
+          </a:prstGeom>
+          <a:noFill/>
+        </p:spPr>
+        <p:txBody>
+          <a:bodyPr wrap="none">
+            <a:spAutoFit/>
+          </a:bodyPr>
+          <a:lstStyle/>
+          <a:p>
+            <a:pPr>
+              <a:defRPr sz="3200" b="1"/>
+            </a:pPr>
             <a:r>
               <a:t>1. Agile Flight Emerges from Multi-Agent Competitive Racing</a:t>
             </a:r>
@@ -5426,46 +6183,131 @@
       </p:sp>
       <p:sp>
         <p:nvSpPr>
-          <p:cNvPr id="3" name="Content Placeholder 2"/>
-          <p:cNvSpPr>
-            <a:spLocks noGrp="1"/>
-          </p:cNvSpPr>
-          <p:nvPr>
-            <p:ph idx="1"/>
-          </p:nvPr>
-        </p:nvSpPr>
-        <p:spPr/>
-        <p:txBody>
-          <a:bodyPr/>
-          <a:lstStyle/>
-          <a:p>
-            <a:r>
-              <a:t>Demonstrates that agile flight capabilities and strategic behavior emerge naturally from</a:t>
-            </a:r>
-          </a:p>
-          <a:p>
-            <a:pPr/>
-            <a:r>
-              <a:t>multi-agent competition with minimal reward engineering, showing how agent interaction</a:t>
-            </a:r>
-          </a:p>
-          <a:p>
-            <a:pPr/>
-            <a:r>
-              <a:t>drives sophisticated behavior.</a:t>
-            </a:r>
-          </a:p>
-          <a:p>
-            <a:pPr/>
-          </a:p>
-          <a:p>
-            <a:pPr/>
+          <p:cNvPr id="3" name="TextBox 2"/>
+          <p:cNvSpPr txBox="1"/>
+          <p:nvPr/>
+        </p:nvSpPr>
+        <p:spPr>
+          <a:xfrm>
+            <a:off x="457200" y="1371600"/>
+            <a:ext cx="8229600" cy="685800"/>
+          </a:xfrm>
+          <a:prstGeom prst="rect">
+            <a:avLst/>
+          </a:prstGeom>
+          <a:noFill/>
+        </p:spPr>
+        <p:txBody>
+          <a:bodyPr wrap="none">
+            <a:spAutoFit/>
+          </a:bodyPr>
+          <a:lstStyle/>
+          <a:p>
+            <a:pPr>
+              <a:defRPr sz="1100">
+                <a:solidFill>
+                  <a:srgbClr val="333333"/>
+                </a:solidFill>
+              </a:defRPr>
+            </a:pPr>
+            <a:r>
+              <a:t>Demonstrates emergent agile flight behavior and strategic reasoning in drones through multi-agent competitive racing with sparse high-level objectives, showing how complex agent capabilities arise from competition.</a:t>
+            </a:r>
+          </a:p>
+        </p:txBody>
+      </p:sp>
+      <p:sp>
+        <p:nvSpPr>
+          <p:cNvPr id="4" name="TextBox 3"/>
+          <p:cNvSpPr txBox="1"/>
+          <p:nvPr/>
+        </p:nvSpPr>
+        <p:spPr>
+          <a:xfrm>
+            <a:off x="457200" y="2057400"/>
+            <a:ext cx="8229600" cy="685800"/>
+          </a:xfrm>
+          <a:prstGeom prst="rect">
+            <a:avLst/>
+          </a:prstGeom>
+          <a:noFill/>
+        </p:spPr>
+        <p:txBody>
+          <a:bodyPr wrap="none">
+            <a:spAutoFit/>
+          </a:bodyPr>
+          <a:lstStyle/>
+          <a:p>
+            <a:pPr>
+              <a:defRPr sz="800"/>
+            </a:pPr>
+          </a:p>
+        </p:txBody>
+      </p:sp>
+      <p:sp>
+        <p:nvSpPr>
+          <p:cNvPr id="5" name="TextBox 4"/>
+          <p:cNvSpPr txBox="1"/>
+          <p:nvPr/>
+        </p:nvSpPr>
+        <p:spPr>
+          <a:xfrm>
+            <a:off x="457200" y="2743200"/>
+            <a:ext cx="8229600" cy="685800"/>
+          </a:xfrm>
+          <a:prstGeom prst="rect">
+            <a:avLst/>
+          </a:prstGeom>
+          <a:noFill/>
+        </p:spPr>
+        <p:txBody>
+          <a:bodyPr wrap="none">
+            <a:spAutoFit/>
+          </a:bodyPr>
+          <a:lstStyle/>
+          <a:p>
+            <a:pPr>
+              <a:defRPr sz="900" i="1">
+                <a:solidFill>
+                  <a:srgbClr val="666666"/>
+                </a:solidFill>
+              </a:defRPr>
+            </a:pPr>
             <a:r>
               <a:t>📍 arXiv • Vineet Pasumarti, Lorenzo Bianchi, Antonio Loquercio</a:t>
             </a:r>
           </a:p>
-          <a:p>
-            <a:pPr/>
+        </p:txBody>
+      </p:sp>
+      <p:sp>
+        <p:nvSpPr>
+          <p:cNvPr id="6" name="TextBox 5"/>
+          <p:cNvSpPr txBox="1"/>
+          <p:nvPr/>
+        </p:nvSpPr>
+        <p:spPr>
+          <a:xfrm>
+            <a:off x="457200" y="3429000"/>
+            <a:ext cx="8229600" cy="685800"/>
+          </a:xfrm>
+          <a:prstGeom prst="rect">
+            <a:avLst/>
+          </a:prstGeom>
+          <a:noFill/>
+        </p:spPr>
+        <p:txBody>
+          <a:bodyPr wrap="none">
+            <a:spAutoFit/>
+          </a:bodyPr>
+          <a:lstStyle/>
+          <a:p>
+            <a:pPr>
+              <a:defRPr sz="800">
+                <a:solidFill>
+                  <a:srgbClr val="3498DB"/>
+                </a:solidFill>
+              </a:defRPr>
+            </a:pPr>
             <a:r>
               <a:t>🔗 https://arxiv.org/abs/2512.11781v1</a:t>
             </a:r>
@@ -5474,7 +6316,7 @@
       </p:sp>
       <p:sp>
         <p:nvSpPr>
-          <p:cNvPr id="4" name="TextBox 3"/>
+          <p:cNvPr id="7" name="TextBox 6"/>
           <p:cNvSpPr txBox="1"/>
           <p:nvPr/>
         </p:nvSpPr>
@@ -5531,61 +6373,162 @@
       <p:grpSpPr/>
       <p:sp>
         <p:nvSpPr>
-          <p:cNvPr id="2" name="Title 1"/>
-          <p:cNvSpPr>
-            <a:spLocks noGrp="1"/>
-          </p:cNvSpPr>
-          <p:nvPr>
-            <p:ph type="title"/>
-          </p:nvPr>
-        </p:nvSpPr>
-        <p:spPr/>
-        <p:txBody>
-          <a:bodyPr/>
-          <a:lstStyle/>
-          <a:p>
-            <a:r>
-              <a:t>2. MedAI: Evaluating TxAgent's Therapeutic Agentic Reasoning in the NeurIPS...</a:t>
-            </a:r>
-          </a:p>
-        </p:txBody>
-      </p:sp>
-      <p:sp>
-        <p:nvSpPr>
-          <p:cNvPr id="3" name="Content Placeholder 2"/>
-          <p:cNvSpPr>
-            <a:spLocks noGrp="1"/>
-          </p:cNvSpPr>
-          <p:nvPr>
-            <p:ph idx="1"/>
-          </p:nvPr>
-        </p:nvSpPr>
-        <p:spPr/>
-        <p:txBody>
-          <a:bodyPr/>
-          <a:lstStyle/>
-          <a:p>
-            <a:r>
-              <a:t>Introduces TxAgent for therapeutic decision-making in clinical medicine, advancing agentic</a:t>
-            </a:r>
-          </a:p>
-          <a:p>
-            <a:pPr/>
-            <a:r>
-              <a:t>reasoning in high-stakes medical domains with complex multi-factor reasoning requirements.</a:t>
-            </a:r>
-          </a:p>
-          <a:p>
-            <a:pPr/>
-          </a:p>
-          <a:p>
-            <a:pPr/>
+          <p:cNvPr id="2" name="TextBox 1"/>
+          <p:cNvSpPr txBox="1"/>
+          <p:nvPr/>
+        </p:nvSpPr>
+        <p:spPr>
+          <a:xfrm>
+            <a:off x="457200" y="457200"/>
+            <a:ext cx="8229600" cy="685800"/>
+          </a:xfrm>
+          <a:prstGeom prst="rect">
+            <a:avLst/>
+          </a:prstGeom>
+          <a:noFill/>
+        </p:spPr>
+        <p:txBody>
+          <a:bodyPr wrap="none">
+            <a:spAutoFit/>
+          </a:bodyPr>
+          <a:lstStyle/>
+          <a:p>
+            <a:pPr>
+              <a:defRPr sz="3200" b="1"/>
+            </a:pPr>
+            <a:r>
+              <a:t>2. MedAI: Evaluating TxAgent's Therapeutic Agentic Reasoning in the NeurIPS CURE-Bench Competition</a:t>
+            </a:r>
+          </a:p>
+        </p:txBody>
+      </p:sp>
+      <p:sp>
+        <p:nvSpPr>
+          <p:cNvPr id="3" name="TextBox 2"/>
+          <p:cNvSpPr txBox="1"/>
+          <p:nvPr/>
+        </p:nvSpPr>
+        <p:spPr>
+          <a:xfrm>
+            <a:off x="457200" y="1371600"/>
+            <a:ext cx="8229600" cy="685800"/>
+          </a:xfrm>
+          <a:prstGeom prst="rect">
+            <a:avLst/>
+          </a:prstGeom>
+          <a:noFill/>
+        </p:spPr>
+        <p:txBody>
+          <a:bodyPr wrap="none">
+            <a:spAutoFit/>
+          </a:bodyPr>
+          <a:lstStyle/>
+          <a:p>
+            <a:pPr>
+              <a:defRPr sz="1100">
+                <a:solidFill>
+                  <a:srgbClr val="333333"/>
+                </a:solidFill>
+              </a:defRPr>
+            </a:pPr>
+            <a:r>
+              <a:t>Presents TxAgent for therapeutic decision-making that demonstrates agentic reasoning in high-stakes clinical medicine through complex multi-step planning and tool use.</a:t>
+            </a:r>
+          </a:p>
+        </p:txBody>
+      </p:sp>
+      <p:sp>
+        <p:nvSpPr>
+          <p:cNvPr id="4" name="TextBox 3"/>
+          <p:cNvSpPr txBox="1"/>
+          <p:nvPr/>
+        </p:nvSpPr>
+        <p:spPr>
+          <a:xfrm>
+            <a:off x="457200" y="2057400"/>
+            <a:ext cx="8229600" cy="685800"/>
+          </a:xfrm>
+          <a:prstGeom prst="rect">
+            <a:avLst/>
+          </a:prstGeom>
+          <a:noFill/>
+        </p:spPr>
+        <p:txBody>
+          <a:bodyPr wrap="none">
+            <a:spAutoFit/>
+          </a:bodyPr>
+          <a:lstStyle/>
+          <a:p>
+            <a:pPr>
+              <a:defRPr sz="800"/>
+            </a:pPr>
+          </a:p>
+        </p:txBody>
+      </p:sp>
+      <p:sp>
+        <p:nvSpPr>
+          <p:cNvPr id="5" name="TextBox 4"/>
+          <p:cNvSpPr txBox="1"/>
+          <p:nvPr/>
+        </p:nvSpPr>
+        <p:spPr>
+          <a:xfrm>
+            <a:off x="457200" y="2743200"/>
+            <a:ext cx="8229600" cy="685800"/>
+          </a:xfrm>
+          <a:prstGeom prst="rect">
+            <a:avLst/>
+          </a:prstGeom>
+          <a:noFill/>
+        </p:spPr>
+        <p:txBody>
+          <a:bodyPr wrap="none">
+            <a:spAutoFit/>
+          </a:bodyPr>
+          <a:lstStyle/>
+          <a:p>
+            <a:pPr>
+              <a:defRPr sz="900" i="1">
+                <a:solidFill>
+                  <a:srgbClr val="666666"/>
+                </a:solidFill>
+              </a:defRPr>
+            </a:pPr>
             <a:r>
               <a:t>📍 arXiv • Tim Cofala, Christian Kalfar, Jingge Xiao</a:t>
             </a:r>
           </a:p>
-          <a:p>
-            <a:pPr/>
+        </p:txBody>
+      </p:sp>
+      <p:sp>
+        <p:nvSpPr>
+          <p:cNvPr id="6" name="TextBox 5"/>
+          <p:cNvSpPr txBox="1"/>
+          <p:nvPr/>
+        </p:nvSpPr>
+        <p:spPr>
+          <a:xfrm>
+            <a:off x="457200" y="3429000"/>
+            <a:ext cx="8229600" cy="685800"/>
+          </a:xfrm>
+          <a:prstGeom prst="rect">
+            <a:avLst/>
+          </a:prstGeom>
+          <a:noFill/>
+        </p:spPr>
+        <p:txBody>
+          <a:bodyPr wrap="none">
+            <a:spAutoFit/>
+          </a:bodyPr>
+          <a:lstStyle/>
+          <a:p>
+            <a:pPr>
+              <a:defRPr sz="800">
+                <a:solidFill>
+                  <a:srgbClr val="3498DB"/>
+                </a:solidFill>
+              </a:defRPr>
+            </a:pPr>
             <a:r>
               <a:t>🔗 https://arxiv.org/abs/2512.11682v1</a:t>
             </a:r>
@@ -5594,7 +6537,7 @@
       </p:sp>
       <p:sp>
         <p:nvSpPr>
-          <p:cNvPr id="4" name="TextBox 3"/>
+          <p:cNvPr id="7" name="TextBox 6"/>
           <p:cNvSpPr txBox="1"/>
           <p:nvPr/>
         </p:nvSpPr>
@@ -5651,61 +6594,162 @@
       <p:grpSpPr/>
       <p:sp>
         <p:nvSpPr>
-          <p:cNvPr id="2" name="Title 1"/>
-          <p:cNvSpPr>
-            <a:spLocks noGrp="1"/>
-          </p:cNvSpPr>
-          <p:nvPr>
-            <p:ph type="title"/>
-          </p:nvPr>
-        </p:nvSpPr>
-        <p:spPr/>
-        <p:txBody>
-          <a:bodyPr/>
-          <a:lstStyle/>
-          <a:p>
-            <a:r>
-              <a:t>3. Bounding Hallucinations: Information-Theoretic Guarantees for RAG System...</a:t>
-            </a:r>
-          </a:p>
-        </p:txBody>
-      </p:sp>
-      <p:sp>
-        <p:nvSpPr>
-          <p:cNvPr id="3" name="Content Placeholder 2"/>
-          <p:cNvSpPr>
-            <a:spLocks noGrp="1"/>
-          </p:cNvSpPr>
-          <p:nvPr>
-            <p:ph idx="1"/>
-          </p:nvPr>
-        </p:nvSpPr>
-        <p:spPr/>
-        <p:txBody>
-          <a:bodyPr/>
-          <a:lstStyle/>
-          <a:p>
-            <a:r>
-              <a:t>Provides theoretical framework for verifiable retrieval in RAG agents using information</a:t>
-            </a:r>
-          </a:p>
-          <a:p>
-            <a:pPr/>
-            <a:r>
-              <a:t>theory, moving beyond heuristic retrieval to provable guarantees against hallucination.</a:t>
-            </a:r>
-          </a:p>
-          <a:p>
-            <a:pPr/>
-          </a:p>
-          <a:p>
-            <a:pPr/>
+          <p:cNvPr id="2" name="TextBox 1"/>
+          <p:cNvSpPr txBox="1"/>
+          <p:nvPr/>
+        </p:nvSpPr>
+        <p:spPr>
+          <a:xfrm>
+            <a:off x="457200" y="457200"/>
+            <a:ext cx="8229600" cy="685800"/>
+          </a:xfrm>
+          <a:prstGeom prst="rect">
+            <a:avLst/>
+          </a:prstGeom>
+          <a:noFill/>
+        </p:spPr>
+        <p:txBody>
+          <a:bodyPr wrap="none">
+            <a:spAutoFit/>
+          </a:bodyPr>
+          <a:lstStyle/>
+          <a:p>
+            <a:pPr>
+              <a:defRPr sz="3200" b="1"/>
+            </a:pPr>
+            <a:r>
+              <a:t>3. Bounding Hallucinations: Information-Theoretic Guarantees for RAG Systems via Merlin-Arthur Protocols</a:t>
+            </a:r>
+          </a:p>
+        </p:txBody>
+      </p:sp>
+      <p:sp>
+        <p:nvSpPr>
+          <p:cNvPr id="3" name="TextBox 2"/>
+          <p:cNvSpPr txBox="1"/>
+          <p:nvPr/>
+        </p:nvSpPr>
+        <p:spPr>
+          <a:xfrm>
+            <a:off x="457200" y="1371600"/>
+            <a:ext cx="8229600" cy="685800"/>
+          </a:xfrm>
+          <a:prstGeom prst="rect">
+            <a:avLst/>
+          </a:prstGeom>
+          <a:noFill/>
+        </p:spPr>
+        <p:txBody>
+          <a:bodyPr wrap="none">
+            <a:spAutoFit/>
+          </a:bodyPr>
+          <a:lstStyle/>
+          <a:p>
+            <a:pPr>
+              <a:defRPr sz="1100">
+                <a:solidFill>
+                  <a:srgbClr val="333333"/>
+                </a:solidFill>
+              </a:defRPr>
+            </a:pPr>
+            <a:r>
+              <a:t>Provides theoretical framework for verifiable retrieval in RAG systems, moving beyond heuristic retrieval to guarantee-backed evidence processing for more reliable agent tool use.</a:t>
+            </a:r>
+          </a:p>
+        </p:txBody>
+      </p:sp>
+      <p:sp>
+        <p:nvSpPr>
+          <p:cNvPr id="4" name="TextBox 3"/>
+          <p:cNvSpPr txBox="1"/>
+          <p:nvPr/>
+        </p:nvSpPr>
+        <p:spPr>
+          <a:xfrm>
+            <a:off x="457200" y="2057400"/>
+            <a:ext cx="8229600" cy="685800"/>
+          </a:xfrm>
+          <a:prstGeom prst="rect">
+            <a:avLst/>
+          </a:prstGeom>
+          <a:noFill/>
+        </p:spPr>
+        <p:txBody>
+          <a:bodyPr wrap="none">
+            <a:spAutoFit/>
+          </a:bodyPr>
+          <a:lstStyle/>
+          <a:p>
+            <a:pPr>
+              <a:defRPr sz="800"/>
+            </a:pPr>
+          </a:p>
+        </p:txBody>
+      </p:sp>
+      <p:sp>
+        <p:nvSpPr>
+          <p:cNvPr id="5" name="TextBox 4"/>
+          <p:cNvSpPr txBox="1"/>
+          <p:nvPr/>
+        </p:nvSpPr>
+        <p:spPr>
+          <a:xfrm>
+            <a:off x="457200" y="2743200"/>
+            <a:ext cx="8229600" cy="685800"/>
+          </a:xfrm>
+          <a:prstGeom prst="rect">
+            <a:avLst/>
+          </a:prstGeom>
+          <a:noFill/>
+        </p:spPr>
+        <p:txBody>
+          <a:bodyPr wrap="none">
+            <a:spAutoFit/>
+          </a:bodyPr>
+          <a:lstStyle/>
+          <a:p>
+            <a:pPr>
+              <a:defRPr sz="900" i="1">
+                <a:solidFill>
+                  <a:srgbClr val="666666"/>
+                </a:solidFill>
+              </a:defRPr>
+            </a:pPr>
             <a:r>
               <a:t>📍 arXiv • Björn Deiseroth, Max Henning Höth, Kristian Kersting</a:t>
             </a:r>
           </a:p>
-          <a:p>
-            <a:pPr/>
+        </p:txBody>
+      </p:sp>
+      <p:sp>
+        <p:nvSpPr>
+          <p:cNvPr id="6" name="TextBox 5"/>
+          <p:cNvSpPr txBox="1"/>
+          <p:nvPr/>
+        </p:nvSpPr>
+        <p:spPr>
+          <a:xfrm>
+            <a:off x="457200" y="3429000"/>
+            <a:ext cx="8229600" cy="685800"/>
+          </a:xfrm>
+          <a:prstGeom prst="rect">
+            <a:avLst/>
+          </a:prstGeom>
+          <a:noFill/>
+        </p:spPr>
+        <p:txBody>
+          <a:bodyPr wrap="none">
+            <a:spAutoFit/>
+          </a:bodyPr>
+          <a:lstStyle/>
+          <a:p>
+            <a:pPr>
+              <a:defRPr sz="800">
+                <a:solidFill>
+                  <a:srgbClr val="3498DB"/>
+                </a:solidFill>
+              </a:defRPr>
+            </a:pPr>
             <a:r>
               <a:t>🔗 https://arxiv.org/abs/2512.11614v1</a:t>
             </a:r>
@@ -5714,7 +6758,7 @@
       </p:sp>
       <p:sp>
         <p:nvSpPr>
-          <p:cNvPr id="4" name="TextBox 3"/>
+          <p:cNvPr id="7" name="TextBox 6"/>
           <p:cNvSpPr txBox="1"/>
           <p:nvPr/>
         </p:nvSpPr>
@@ -5771,61 +6815,162 @@
       <p:grpSpPr/>
       <p:sp>
         <p:nvSpPr>
-          <p:cNvPr id="2" name="Title 1"/>
-          <p:cNvSpPr>
-            <a:spLocks noGrp="1"/>
-          </p:cNvSpPr>
-          <p:nvPr>
-            <p:ph type="title"/>
-          </p:nvPr>
-        </p:nvSpPr>
-        <p:spPr/>
-        <p:txBody>
-          <a:bodyPr/>
-          <a:lstStyle/>
-          <a:p>
-            <a:r>
-              <a:t>4. From Verification Burden to Trusted Collaboration: Design Goals for LLM-...</a:t>
-            </a:r>
-          </a:p>
-        </p:txBody>
-      </p:sp>
-      <p:sp>
-        <p:nvSpPr>
-          <p:cNvPr id="3" name="Content Placeholder 2"/>
-          <p:cNvSpPr>
-            <a:spLocks noGrp="1"/>
-          </p:cNvSpPr>
-          <p:nvPr>
-            <p:ph idx="1"/>
-          </p:nvPr>
-        </p:nvSpPr>
-        <p:spPr/>
-        <p:txBody>
-          <a:bodyPr/>
-          <a:lstStyle/>
-          <a:p>
-            <a:r>
-              <a:t>Explores design principles for LLM agents in academic workflows, addressing the critical</a:t>
-            </a:r>
-          </a:p>
-          <a:p>
-            <a:pPr/>
-            <a:r>
-              <a:t>challenge of building trust in AI-assisted research tasks.</a:t>
-            </a:r>
-          </a:p>
-          <a:p>
-            <a:pPr/>
-          </a:p>
-          <a:p>
-            <a:pPr/>
+          <p:cNvPr id="2" name="TextBox 1"/>
+          <p:cNvSpPr txBox="1"/>
+          <p:nvPr/>
+        </p:nvSpPr>
+        <p:spPr>
+          <a:xfrm>
+            <a:off x="457200" y="457200"/>
+            <a:ext cx="8229600" cy="685800"/>
+          </a:xfrm>
+          <a:prstGeom prst="rect">
+            <a:avLst/>
+          </a:prstGeom>
+          <a:noFill/>
+        </p:spPr>
+        <p:txBody>
+          <a:bodyPr wrap="none">
+            <a:spAutoFit/>
+          </a:bodyPr>
+          <a:lstStyle/>
+          <a:p>
+            <a:pPr>
+              <a:defRPr sz="3200" b="1"/>
+            </a:pPr>
+            <a:r>
+              <a:t>4. From Verification Burden to Trusted Collaboration: Design Goals for LLM-Assisted Literature Reviews</a:t>
+            </a:r>
+          </a:p>
+        </p:txBody>
+      </p:sp>
+      <p:sp>
+        <p:nvSpPr>
+          <p:cNvPr id="3" name="TextBox 2"/>
+          <p:cNvSpPr txBox="1"/>
+          <p:nvPr/>
+        </p:nvSpPr>
+        <p:spPr>
+          <a:xfrm>
+            <a:off x="457200" y="1371600"/>
+            <a:ext cx="8229600" cy="685800"/>
+          </a:xfrm>
+          <a:prstGeom prst="rect">
+            <a:avLst/>
+          </a:prstGeom>
+          <a:noFill/>
+        </p:spPr>
+        <p:txBody>
+          <a:bodyPr wrap="none">
+            <a:spAutoFit/>
+          </a:bodyPr>
+          <a:lstStyle/>
+          <a:p>
+            <a:pPr>
+              <a:defRPr sz="1100">
+                <a:solidFill>
+                  <a:srgbClr val="333333"/>
+                </a:solidFill>
+              </a:defRPr>
+            </a:pPr>
+            <a:r>
+              <a:t>Explores concrete usage patterns of LLM agents in academic workflows, identifying design requirements for trusted human-AI collaboration in complex reasoning tasks.</a:t>
+            </a:r>
+          </a:p>
+        </p:txBody>
+      </p:sp>
+      <p:sp>
+        <p:nvSpPr>
+          <p:cNvPr id="4" name="TextBox 3"/>
+          <p:cNvSpPr txBox="1"/>
+          <p:nvPr/>
+        </p:nvSpPr>
+        <p:spPr>
+          <a:xfrm>
+            <a:off x="457200" y="2057400"/>
+            <a:ext cx="8229600" cy="685800"/>
+          </a:xfrm>
+          <a:prstGeom prst="rect">
+            <a:avLst/>
+          </a:prstGeom>
+          <a:noFill/>
+        </p:spPr>
+        <p:txBody>
+          <a:bodyPr wrap="none">
+            <a:spAutoFit/>
+          </a:bodyPr>
+          <a:lstStyle/>
+          <a:p>
+            <a:pPr>
+              <a:defRPr sz="800"/>
+            </a:pPr>
+          </a:p>
+        </p:txBody>
+      </p:sp>
+      <p:sp>
+        <p:nvSpPr>
+          <p:cNvPr id="5" name="TextBox 4"/>
+          <p:cNvSpPr txBox="1"/>
+          <p:nvPr/>
+        </p:nvSpPr>
+        <p:spPr>
+          <a:xfrm>
+            <a:off x="457200" y="2743200"/>
+            <a:ext cx="8229600" cy="685800"/>
+          </a:xfrm>
+          <a:prstGeom prst="rect">
+            <a:avLst/>
+          </a:prstGeom>
+          <a:noFill/>
+        </p:spPr>
+        <p:txBody>
+          <a:bodyPr wrap="none">
+            <a:spAutoFit/>
+          </a:bodyPr>
+          <a:lstStyle/>
+          <a:p>
+            <a:pPr>
+              <a:defRPr sz="900" i="1">
+                <a:solidFill>
+                  <a:srgbClr val="666666"/>
+                </a:solidFill>
+              </a:defRPr>
+            </a:pPr>
             <a:r>
               <a:t>📍 arXiv • Brenda Nogueira, Werner Geyer, Andrew Anderson</a:t>
             </a:r>
           </a:p>
-          <a:p>
-            <a:pPr/>
+        </p:txBody>
+      </p:sp>
+      <p:sp>
+        <p:nvSpPr>
+          <p:cNvPr id="6" name="TextBox 5"/>
+          <p:cNvSpPr txBox="1"/>
+          <p:nvPr/>
+        </p:nvSpPr>
+        <p:spPr>
+          <a:xfrm>
+            <a:off x="457200" y="3429000"/>
+            <a:ext cx="8229600" cy="685800"/>
+          </a:xfrm>
+          <a:prstGeom prst="rect">
+            <a:avLst/>
+          </a:prstGeom>
+          <a:noFill/>
+        </p:spPr>
+        <p:txBody>
+          <a:bodyPr wrap="none">
+            <a:spAutoFit/>
+          </a:bodyPr>
+          <a:lstStyle/>
+          <a:p>
+            <a:pPr>
+              <a:defRPr sz="800">
+                <a:solidFill>
+                  <a:srgbClr val="3498DB"/>
+                </a:solidFill>
+              </a:defRPr>
+            </a:pPr>
             <a:r>
               <a:t>🔗 https://arxiv.org/abs/2512.11661v1</a:t>
             </a:r>
@@ -5834,7 +6979,7 @@
       </p:sp>
       <p:sp>
         <p:nvSpPr>
-          <p:cNvPr id="4" name="TextBox 3"/>
+          <p:cNvPr id="7" name="TextBox 6"/>
           <p:cNvSpPr txBox="1"/>
           <p:nvPr/>
         </p:nvSpPr>
@@ -5891,67 +7036,162 @@
       <p:grpSpPr/>
       <p:sp>
         <p:nvSpPr>
-          <p:cNvPr id="2" name="Title 1"/>
-          <p:cNvSpPr>
-            <a:spLocks noGrp="1"/>
-          </p:cNvSpPr>
-          <p:nvPr>
-            <p:ph type="title"/>
-          </p:nvPr>
-        </p:nvSpPr>
-        <p:spPr/>
-        <p:txBody>
-          <a:bodyPr/>
-          <a:lstStyle/>
-          <a:p>
-            <a:r>
-              <a:t>5. LUCID: Learning-Enabled Uncertainty-Aware Certification of Stochastic Dy...</a:t>
-            </a:r>
-          </a:p>
-        </p:txBody>
-      </p:sp>
-      <p:sp>
-        <p:nvSpPr>
-          <p:cNvPr id="3" name="Content Placeholder 2"/>
-          <p:cNvSpPr>
-            <a:spLocks noGrp="1"/>
-          </p:cNvSpPr>
-          <p:nvPr>
-            <p:ph idx="1"/>
-          </p:nvPr>
-        </p:nvSpPr>
-        <p:spPr/>
-        <p:txBody>
-          <a:bodyPr/>
-          <a:lstStyle/>
-          <a:p>
-            <a:r>
-              <a:t>Addresses formal verification of AI-enabled autonomous systems with uncertainty</a:t>
-            </a:r>
-          </a:p>
-          <a:p>
-            <a:pPr/>
-            <a:r>
-              <a:t>quantification, crucial for deploying agents in safety-critical applications like</a:t>
-            </a:r>
-          </a:p>
-          <a:p>
-            <a:pPr/>
-            <a:r>
-              <a:t>autonomous driving.</a:t>
-            </a:r>
-          </a:p>
-          <a:p>
-            <a:pPr/>
-          </a:p>
-          <a:p>
-            <a:pPr/>
+          <p:cNvPr id="2" name="TextBox 1"/>
+          <p:cNvSpPr txBox="1"/>
+          <p:nvPr/>
+        </p:nvSpPr>
+        <p:spPr>
+          <a:xfrm>
+            <a:off x="457200" y="457200"/>
+            <a:ext cx="8229600" cy="685800"/>
+          </a:xfrm>
+          <a:prstGeom prst="rect">
+            <a:avLst/>
+          </a:prstGeom>
+          <a:noFill/>
+        </p:spPr>
+        <p:txBody>
+          <a:bodyPr wrap="none">
+            <a:spAutoFit/>
+          </a:bodyPr>
+          <a:lstStyle/>
+          <a:p>
+            <a:pPr>
+              <a:defRPr sz="3200" b="1"/>
+            </a:pPr>
+            <a:r>
+              <a:t>5. LUCID: Learning-Enabled Uncertainty-Aware Certification of Stochastic Dynamical Systems</a:t>
+            </a:r>
+          </a:p>
+        </p:txBody>
+      </p:sp>
+      <p:sp>
+        <p:nvSpPr>
+          <p:cNvPr id="3" name="TextBox 2"/>
+          <p:cNvSpPr txBox="1"/>
+          <p:nvPr/>
+        </p:nvSpPr>
+        <p:spPr>
+          <a:xfrm>
+            <a:off x="457200" y="1371600"/>
+            <a:ext cx="8229600" cy="685800"/>
+          </a:xfrm>
+          <a:prstGeom prst="rect">
+            <a:avLst/>
+          </a:prstGeom>
+          <a:noFill/>
+        </p:spPr>
+        <p:txBody>
+          <a:bodyPr wrap="none">
+            <a:spAutoFit/>
+          </a:bodyPr>
+          <a:lstStyle/>
+          <a:p>
+            <a:pPr>
+              <a:defRPr sz="1100">
+                <a:solidFill>
+                  <a:srgbClr val="333333"/>
+                </a:solidFill>
+              </a:defRPr>
+            </a:pPr>
+            <a:r>
+              <a:t>Addresses formal verification challenges for AI-enabled autonomous systems, providing certification methods critical for deploying agents in safety-critical domains like autonomous driving.</a:t>
+            </a:r>
+          </a:p>
+        </p:txBody>
+      </p:sp>
+      <p:sp>
+        <p:nvSpPr>
+          <p:cNvPr id="4" name="TextBox 3"/>
+          <p:cNvSpPr txBox="1"/>
+          <p:nvPr/>
+        </p:nvSpPr>
+        <p:spPr>
+          <a:xfrm>
+            <a:off x="457200" y="2057400"/>
+            <a:ext cx="8229600" cy="685800"/>
+          </a:xfrm>
+          <a:prstGeom prst="rect">
+            <a:avLst/>
+          </a:prstGeom>
+          <a:noFill/>
+        </p:spPr>
+        <p:txBody>
+          <a:bodyPr wrap="none">
+            <a:spAutoFit/>
+          </a:bodyPr>
+          <a:lstStyle/>
+          <a:p>
+            <a:pPr>
+              <a:defRPr sz="800"/>
+            </a:pPr>
+          </a:p>
+        </p:txBody>
+      </p:sp>
+      <p:sp>
+        <p:nvSpPr>
+          <p:cNvPr id="5" name="TextBox 4"/>
+          <p:cNvSpPr txBox="1"/>
+          <p:nvPr/>
+        </p:nvSpPr>
+        <p:spPr>
+          <a:xfrm>
+            <a:off x="457200" y="2743200"/>
+            <a:ext cx="8229600" cy="685800"/>
+          </a:xfrm>
+          <a:prstGeom prst="rect">
+            <a:avLst/>
+          </a:prstGeom>
+          <a:noFill/>
+        </p:spPr>
+        <p:txBody>
+          <a:bodyPr wrap="none">
+            <a:spAutoFit/>
+          </a:bodyPr>
+          <a:lstStyle/>
+          <a:p>
+            <a:pPr>
+              <a:defRPr sz="900" i="1">
+                <a:solidFill>
+                  <a:srgbClr val="666666"/>
+                </a:solidFill>
+              </a:defRPr>
+            </a:pPr>
             <a:r>
               <a:t>📍 arXiv • Ernesto Casablanca, Oliver Schön, Paolo Zuliani</a:t>
             </a:r>
           </a:p>
-          <a:p>
-            <a:pPr/>
+        </p:txBody>
+      </p:sp>
+      <p:sp>
+        <p:nvSpPr>
+          <p:cNvPr id="6" name="TextBox 5"/>
+          <p:cNvSpPr txBox="1"/>
+          <p:nvPr/>
+        </p:nvSpPr>
+        <p:spPr>
+          <a:xfrm>
+            <a:off x="457200" y="3429000"/>
+            <a:ext cx="8229600" cy="685800"/>
+          </a:xfrm>
+          <a:prstGeom prst="rect">
+            <a:avLst/>
+          </a:prstGeom>
+          <a:noFill/>
+        </p:spPr>
+        <p:txBody>
+          <a:bodyPr wrap="none">
+            <a:spAutoFit/>
+          </a:bodyPr>
+          <a:lstStyle/>
+          <a:p>
+            <a:pPr>
+              <a:defRPr sz="800">
+                <a:solidFill>
+                  <a:srgbClr val="3498DB"/>
+                </a:solidFill>
+              </a:defRPr>
+            </a:pPr>
             <a:r>
               <a:t>🔗 https://arxiv.org/abs/2512.11750v1</a:t>
             </a:r>
@@ -5960,7 +7200,7 @@
       </p:sp>
       <p:sp>
         <p:nvSpPr>
-          <p:cNvPr id="4" name="TextBox 3"/>
+          <p:cNvPr id="7" name="TextBox 6"/>
           <p:cNvSpPr txBox="1"/>
           <p:nvPr/>
         </p:nvSpPr>
@@ -6017,19 +7257,29 @@
       <p:grpSpPr/>
       <p:sp>
         <p:nvSpPr>
-          <p:cNvPr id="2" name="Title 1"/>
-          <p:cNvSpPr>
-            <a:spLocks noGrp="1"/>
-          </p:cNvSpPr>
-          <p:nvPr>
-            <p:ph type="title"/>
-          </p:nvPr>
-        </p:nvSpPr>
-        <p:spPr/>
-        <p:txBody>
-          <a:bodyPr/>
-          <a:lstStyle/>
-          <a:p>
+          <p:cNvPr id="2" name="TextBox 1"/>
+          <p:cNvSpPr txBox="1"/>
+          <p:nvPr/>
+        </p:nvSpPr>
+        <p:spPr>
+          <a:xfrm>
+            <a:off x="457200" y="457200"/>
+            <a:ext cx="8229600" cy="685800"/>
+          </a:xfrm>
+          <a:prstGeom prst="rect">
+            <a:avLst/>
+          </a:prstGeom>
+          <a:noFill/>
+        </p:spPr>
+        <p:txBody>
+          <a:bodyPr wrap="none">
+            <a:spAutoFit/>
+          </a:bodyPr>
+          <a:lstStyle/>
+          <a:p>
+            <a:pPr>
+              <a:defRPr sz="3200" b="1"/>
+            </a:pPr>
             <a:r>
               <a:t>🏢 Industry Updates</a:t>
             </a:r>
@@ -6038,28 +7288,96 @@
       </p:sp>
       <p:sp>
         <p:nvSpPr>
-          <p:cNvPr id="3" name="Content Placeholder 2"/>
-          <p:cNvSpPr>
-            <a:spLocks noGrp="1"/>
-          </p:cNvSpPr>
-          <p:nvPr>
-            <p:ph idx="1"/>
-          </p:nvPr>
-        </p:nvSpPr>
-        <p:spPr/>
-        <p:txBody>
-          <a:bodyPr/>
-          <a:lstStyle/>
-          <a:p>
+          <p:cNvPr id="3" name="TextBox 2"/>
+          <p:cNvSpPr txBox="1"/>
+          <p:nvPr/>
+        </p:nvSpPr>
+        <p:spPr>
+          <a:xfrm>
+            <a:off x="457200" y="1371600"/>
+            <a:ext cx="8229600" cy="685800"/>
+          </a:xfrm>
+          <a:prstGeom prst="rect">
+            <a:avLst/>
+          </a:prstGeom>
+          <a:noFill/>
+        </p:spPr>
+        <p:txBody>
+          <a:bodyPr wrap="none">
+            <a:spAutoFit/>
+          </a:bodyPr>
+          <a:lstStyle/>
+          <a:p>
+            <a:pPr>
+              <a:defRPr sz="1800" b="1">
+                <a:solidFill>
+                  <a:srgbClr val="FFFFFF"/>
+                </a:solidFill>
+              </a:defRPr>
+            </a:pPr>
             <a:r>
               <a:t>5 key updates this week</a:t>
             </a:r>
           </a:p>
-          <a:p>
-            <a:pPr/>
-          </a:p>
-          <a:p>
-            <a:pPr/>
+        </p:txBody>
+      </p:sp>
+      <p:sp>
+        <p:nvSpPr>
+          <p:cNvPr id="4" name="TextBox 3"/>
+          <p:cNvSpPr txBox="1"/>
+          <p:nvPr/>
+        </p:nvSpPr>
+        <p:spPr>
+          <a:xfrm>
+            <a:off x="457200" y="2057400"/>
+            <a:ext cx="8229600" cy="685800"/>
+          </a:xfrm>
+          <a:prstGeom prst="rect">
+            <a:avLst/>
+          </a:prstGeom>
+          <a:noFill/>
+        </p:spPr>
+        <p:txBody>
+          <a:bodyPr wrap="none">
+            <a:spAutoFit/>
+          </a:bodyPr>
+          <a:lstStyle/>
+          <a:p>
+            <a:pPr>
+              <a:defRPr sz="1200"/>
+            </a:pPr>
+          </a:p>
+        </p:txBody>
+      </p:sp>
+      <p:sp>
+        <p:nvSpPr>
+          <p:cNvPr id="5" name="TextBox 4"/>
+          <p:cNvSpPr txBox="1"/>
+          <p:nvPr/>
+        </p:nvSpPr>
+        <p:spPr>
+          <a:xfrm>
+            <a:off x="457200" y="2743200"/>
+            <a:ext cx="8229600" cy="685800"/>
+          </a:xfrm>
+          <a:prstGeom prst="rect">
+            <a:avLst/>
+          </a:prstGeom>
+          <a:noFill/>
+        </p:spPr>
+        <p:txBody>
+          <a:bodyPr wrap="none">
+            <a:spAutoFit/>
+          </a:bodyPr>
+          <a:lstStyle/>
+          <a:p>
+            <a:pPr>
+              <a:defRPr sz="1400" i="1">
+                <a:solidFill>
+                  <a:srgbClr val="FFFFFF"/>
+                </a:solidFill>
+              </a:defRPr>
+            </a:pPr>
             <a:r>
               <a:t>→ Swipe to explore</a:t>
             </a:r>
@@ -6068,7 +7386,7 @@
       </p:sp>
       <p:sp>
         <p:nvSpPr>
-          <p:cNvPr id="4" name="TextBox 3"/>
+          <p:cNvPr id="6" name="TextBox 5"/>
           <p:cNvSpPr txBox="1"/>
           <p:nvPr/>
         </p:nvSpPr>

</xml_diff>